<commit_message>
FSM use cases: abstraction of C&C languages
</commit_message>
<xml_diff>
--- a/products/syse_functions/doc/FunctionStructure.UseCases.pptx
+++ b/products/syse_functions/doc/FunctionStructure.UseCases.pptx
@@ -5,19 +5,20 @@
     <p:sldMasterId id="2147483934" r:id="rId1"/>
   </p:sldMasterIdLst>
   <p:notesMasterIdLst>
-    <p:notesMasterId r:id="rId4"/>
+    <p:notesMasterId r:id="rId5"/>
   </p:notesMasterIdLst>
   <p:handoutMasterIdLst>
-    <p:handoutMasterId r:id="rId5"/>
+    <p:handoutMasterId r:id="rId6"/>
   </p:handoutMasterIdLst>
   <p:sldIdLst>
-    <p:sldId id="2147376258" r:id="rId2"/>
-    <p:sldId id="2147376259" r:id="rId3"/>
+    <p:sldId id="2147376260" r:id="rId2"/>
+    <p:sldId id="2147376258" r:id="rId3"/>
+    <p:sldId id="2147376259" r:id="rId4"/>
   </p:sldIdLst>
   <p:sldSz cx="12192000" cy="6858000"/>
   <p:notesSz cx="6797675" cy="9926638"/>
   <p:custDataLst>
-    <p:tags r:id="rId6"/>
+    <p:tags r:id="rId7"/>
   </p:custDataLst>
   <p:defaultTextStyle>
     <a:defPPr>
@@ -149,6 +150,7 @@
       <p14:sectionLst xmlns:p14="http://schemas.microsoft.com/office/powerpoint/2010/main">
         <p14:section name="DTCockpit" id="{06361524-1C3F-41AC-9E10-21EE49FEBC5C}">
           <p14:sldIdLst>
+            <p14:sldId id="2147376260"/>
             <p14:sldId id="2147376258"/>
             <p14:sldId id="2147376259"/>
           </p14:sldIdLst>
@@ -9304,7 +9306,7 @@
             <a:fld id="{935FA329-B071-4BC1-BBB5-3B07BBB55D93}" type="slidenum">
               <a:rPr lang="de-DE" altLang="de-DE"/>
               <a:pPr/>
-              <a:t>‹Nr.›</a:t>
+              <a:t>‹#›</a:t>
             </a:fld>
             <a:endParaRPr lang="de-DE" altLang="de-DE"/>
           </a:p>
@@ -9611,7 +9613,7 @@
             <a:fld id="{1BC8D279-B8BC-4FA6-86F2-E41329D88EBB}" type="slidenum">
               <a:rPr lang="de-DE" altLang="de-DE"/>
               <a:pPr/>
-              <a:t>‹Nr.›</a:t>
+              <a:t>‹#›</a:t>
             </a:fld>
             <a:endParaRPr lang="de-DE" altLang="de-DE"/>
           </a:p>
@@ -9751,6 +9753,85 @@
   <p:cSld>
     <p:spTree>
       <p:nvGrpSpPr>
+        <p:cNvPr id="1" name="">
+          <a:extLst>
+            <a:ext uri="{FF2B5EF4-FFF2-40B4-BE49-F238E27FC236}">
+              <a16:creationId xmlns:a16="http://schemas.microsoft.com/office/drawing/2014/main" id="{169AD8C6-F614-13BA-A281-843851C034E4}"/>
+            </a:ext>
+          </a:extLst>
+        </p:cNvPr>
+        <p:cNvGrpSpPr/>
+        <p:nvPr/>
+      </p:nvGrpSpPr>
+      <p:grpSpPr>
+        <a:xfrm>
+          <a:off x="0" y="0"/>
+          <a:ext cx="0" cy="0"/>
+          <a:chOff x="0" y="0"/>
+          <a:chExt cx="0" cy="0"/>
+        </a:xfrm>
+      </p:grpSpPr>
+      <p:sp>
+        <p:nvSpPr>
+          <p:cNvPr id="2" name="Folienbildplatzhalter 1">
+            <a:extLst>
+              <a:ext uri="{FF2B5EF4-FFF2-40B4-BE49-F238E27FC236}">
+                <a16:creationId xmlns:a16="http://schemas.microsoft.com/office/drawing/2014/main" id="{230800F9-2734-DCA6-36B0-AC5A5BA2B5DA}"/>
+              </a:ext>
+            </a:extLst>
+          </p:cNvPr>
+          <p:cNvSpPr>
+            <a:spLocks noGrp="1" noRot="1" noChangeAspect="1"/>
+          </p:cNvSpPr>
+          <p:nvPr>
+            <p:ph type="sldImg"/>
+          </p:nvPr>
+        </p:nvSpPr>
+        <p:spPr/>
+      </p:sp>
+      <p:sp>
+        <p:nvSpPr>
+          <p:cNvPr id="3" name="Notizenplatzhalter 2">
+            <a:extLst>
+              <a:ext uri="{FF2B5EF4-FFF2-40B4-BE49-F238E27FC236}">
+                <a16:creationId xmlns:a16="http://schemas.microsoft.com/office/drawing/2014/main" id="{C579504E-927D-8B09-4490-159DA01E5E4B}"/>
+              </a:ext>
+            </a:extLst>
+          </p:cNvPr>
+          <p:cNvSpPr>
+            <a:spLocks noGrp="1"/>
+          </p:cNvSpPr>
+          <p:nvPr>
+            <p:ph type="body" idx="1"/>
+          </p:nvPr>
+        </p:nvSpPr>
+        <p:spPr/>
+        <p:txBody>
+          <a:bodyPr/>
+          <a:lstStyle/>
+          <a:p>
+            <a:endParaRPr lang="en-US" dirty="0"/>
+          </a:p>
+        </p:txBody>
+      </p:sp>
+    </p:spTree>
+    <p:extLst>
+      <p:ext uri="{BB962C8B-B14F-4D97-AF65-F5344CB8AC3E}">
+        <p14:creationId xmlns:p14="http://schemas.microsoft.com/office/powerpoint/2010/main" val="2371359003"/>
+      </p:ext>
+    </p:extLst>
+  </p:cSld>
+  <p:clrMapOvr>
+    <a:masterClrMapping/>
+  </p:clrMapOvr>
+</p:notes>
+</file>
+
+<file path=ppt/notesSlides/notesSlide2.xml><?xml version="1.0" encoding="utf-8"?>
+<p:notes xmlns:a="http://schemas.openxmlformats.org/drawingml/2006/main" xmlns:r="http://schemas.openxmlformats.org/officeDocument/2006/relationships" xmlns:p="http://schemas.openxmlformats.org/presentationml/2006/main">
+  <p:cSld>
+    <p:spTree>
+      <p:nvGrpSpPr>
         <p:cNvPr id="1" name=""/>
         <p:cNvGrpSpPr/>
         <p:nvPr/>
@@ -9860,7 +9941,7 @@
           <a:noFill/>
           <a:extLst>
             <a:ext uri="{909E8E84-426E-40dd-AFC4-6F175D3DCCD1}">
-              <a14:hiddenFill xmlns="" xmlns:a14="http://schemas.microsoft.com/office/drawing/2010/main">
+              <a14:hiddenFill xmlns:a14="http://schemas.microsoft.com/office/drawing/2010/main" xmlns="">
                 <a:solidFill>
                   <a:srgbClr val="FFFFFF"/>
                 </a:solidFill>
@@ -11416,7 +11497,7 @@
           <a:noFill/>
           <a:extLst>
             <a:ext uri="{909E8E84-426E-40dd-AFC4-6F175D3DCCD1}">
-              <a14:hiddenFill xmlns="" xmlns:a14="http://schemas.microsoft.com/office/drawing/2010/main">
+              <a14:hiddenFill xmlns:a14="http://schemas.microsoft.com/office/drawing/2010/main" xmlns="">
                 <a:solidFill>
                   <a:srgbClr val="FFFFFF"/>
                 </a:solidFill>
@@ -12426,7 +12507,7 @@
           <a:noFill/>
           <a:extLst>
             <a:ext uri="{909E8E84-426E-40dd-AFC4-6F175D3DCCD1}">
-              <a14:hiddenFill xmlns="" xmlns:a14="http://schemas.microsoft.com/office/drawing/2010/main">
+              <a14:hiddenFill xmlns:a14="http://schemas.microsoft.com/office/drawing/2010/main" xmlns="">
                 <a:solidFill>
                   <a:srgbClr val="FFFFFF"/>
                 </a:solidFill>
@@ -12829,7 +12910,7 @@
           <a:noFill/>
           <a:extLst>
             <a:ext uri="{909E8E84-426E-40dd-AFC4-6F175D3DCCD1}">
-              <a14:hiddenFill xmlns="" xmlns:a14="http://schemas.microsoft.com/office/drawing/2010/main">
+              <a14:hiddenFill xmlns:a14="http://schemas.microsoft.com/office/drawing/2010/main" xmlns="">
                 <a:solidFill>
                   <a:srgbClr val="FFFFFF"/>
                 </a:solidFill>
@@ -13632,7 +13713,7 @@
           <a:noFill/>
           <a:extLst>
             <a:ext uri="{909E8E84-426E-40dd-AFC4-6F175D3DCCD1}">
-              <a14:hiddenFill xmlns="" xmlns:a14="http://schemas.microsoft.com/office/drawing/2010/main">
+              <a14:hiddenFill xmlns:a14="http://schemas.microsoft.com/office/drawing/2010/main" xmlns="">
                 <a:solidFill>
                   <a:srgbClr val="FFFFFF"/>
                 </a:solidFill>
@@ -14293,7 +14374,7 @@
                 </a:solidFill>
               </a:rPr>
               <a:pPr eaLnBrk="1" hangingPunct="1"/>
-              <a:t>‹Nr.›</a:t>
+              <a:t>‹#›</a:t>
             </a:fld>
             <a:endParaRPr lang="de-DE" altLang="de-DE" sz="900" dirty="0">
               <a:solidFill>
@@ -14339,7 +14420,7 @@
           <a:noFill/>
           <a:extLst>
             <a:ext uri="{909E8E84-426E-40dd-AFC4-6F175D3DCCD1}">
-              <a14:hiddenFill xmlns="" xmlns:a14="http://schemas.microsoft.com/office/drawing/2010/main">
+              <a14:hiddenFill xmlns:a14="http://schemas.microsoft.com/office/drawing/2010/main" xmlns="">
                 <a:solidFill>
                   <a:srgbClr val="FFFFFF"/>
                 </a:solidFill>
@@ -15365,6 +15446,3501 @@
 </file>
 
 <file path=ppt/slides/slide1.xml><?xml version="1.0" encoding="utf-8"?>
+<p:sld xmlns:a="http://schemas.openxmlformats.org/drawingml/2006/main" xmlns:r="http://schemas.openxmlformats.org/officeDocument/2006/relationships" xmlns:p="http://schemas.openxmlformats.org/presentationml/2006/main">
+  <p:cSld>
+    <p:spTree>
+      <p:nvGrpSpPr>
+        <p:cNvPr id="1" name="">
+          <a:extLst>
+            <a:ext uri="{FF2B5EF4-FFF2-40B4-BE49-F238E27FC236}">
+              <a16:creationId xmlns:a16="http://schemas.microsoft.com/office/drawing/2014/main" id="{51361A04-55F7-F7C3-8888-D2E07E11DD50}"/>
+            </a:ext>
+          </a:extLst>
+        </p:cNvPr>
+        <p:cNvGrpSpPr/>
+        <p:nvPr/>
+      </p:nvGrpSpPr>
+      <p:grpSpPr>
+        <a:xfrm>
+          <a:off x="0" y="0"/>
+          <a:ext cx="0" cy="0"/>
+          <a:chOff x="0" y="0"/>
+          <a:chExt cx="0" cy="0"/>
+        </a:xfrm>
+      </p:grpSpPr>
+      <p:sp>
+        <p:nvSpPr>
+          <p:cNvPr id="3" name="Titel 2">
+            <a:extLst>
+              <a:ext uri="{FF2B5EF4-FFF2-40B4-BE49-F238E27FC236}">
+                <a16:creationId xmlns:a16="http://schemas.microsoft.com/office/drawing/2014/main" id="{B7C1C066-FC65-0EAB-E152-507387427E1D}"/>
+              </a:ext>
+            </a:extLst>
+          </p:cNvPr>
+          <p:cNvSpPr>
+            <a:spLocks noGrp="1"/>
+          </p:cNvSpPr>
+          <p:nvPr>
+            <p:ph type="title"/>
+          </p:nvPr>
+        </p:nvSpPr>
+        <p:spPr/>
+        <p:txBody>
+          <a:bodyPr/>
+          <a:lstStyle/>
+          <a:p>
+            <a:r>
+              <a:rPr lang="en-US" dirty="0"/>
+              <a:t>Abstraction of C&amp;C languages</a:t>
+            </a:r>
+          </a:p>
+        </p:txBody>
+      </p:sp>
+      <p:grpSp>
+        <p:nvGrpSpPr>
+          <p:cNvPr id="51" name="Gruppieren 50">
+            <a:extLst>
+              <a:ext uri="{FF2B5EF4-FFF2-40B4-BE49-F238E27FC236}">
+                <a16:creationId xmlns:a16="http://schemas.microsoft.com/office/drawing/2014/main" id="{D1E16BE5-FB62-D420-5DF7-240A90D62C8C}"/>
+              </a:ext>
+            </a:extLst>
+          </p:cNvPr>
+          <p:cNvGrpSpPr/>
+          <p:nvPr/>
+        </p:nvGrpSpPr>
+        <p:grpSpPr>
+          <a:xfrm>
+            <a:off x="48391" y="945647"/>
+            <a:ext cx="3006257" cy="3316007"/>
+            <a:chOff x="1247387" y="2478840"/>
+            <a:chExt cx="3614574" cy="3316007"/>
+          </a:xfrm>
+        </p:grpSpPr>
+        <p:sp>
+          <p:nvSpPr>
+            <p:cNvPr id="52" name="Text Box 3">
+              <a:extLst>
+                <a:ext uri="{FF2B5EF4-FFF2-40B4-BE49-F238E27FC236}">
+                  <a16:creationId xmlns:a16="http://schemas.microsoft.com/office/drawing/2014/main" id="{3C0CE501-CBD2-2E07-D053-490B748B1DE9}"/>
+                </a:ext>
+              </a:extLst>
+            </p:cNvPr>
+            <p:cNvSpPr txBox="1">
+              <a:spLocks noChangeArrowheads="1"/>
+            </p:cNvSpPr>
+            <p:nvPr/>
+          </p:nvSpPr>
+          <p:spPr bwMode="auto">
+            <a:xfrm>
+              <a:off x="1763689" y="2478840"/>
+              <a:ext cx="3098272" cy="3293209"/>
+            </a:xfrm>
+            <a:prstGeom prst="rect">
+              <a:avLst/>
+            </a:prstGeom>
+            <a:noFill/>
+            <a:ln w="9525">
+              <a:solidFill>
+                <a:schemeClr val="tx1"/>
+              </a:solidFill>
+              <a:miter lim="800000"/>
+              <a:headEnd/>
+              <a:tailEnd/>
+            </a:ln>
+            <a:effectLst/>
+          </p:spPr>
+          <p:txBody>
+            <a:bodyPr wrap="square">
+              <a:spAutoFit/>
+            </a:bodyPr>
+            <a:lstStyle/>
+            <a:p>
+              <a:r>
+                <a:rPr lang="en-US" sz="1600" b="1" dirty="0">
+                  <a:latin typeface="Courier New" pitchFamily="49" charset="0"/>
+                  <a:cs typeface="Courier New" pitchFamily="49" charset="0"/>
+                </a:rPr>
+                <a:t>component F {</a:t>
+              </a:r>
+            </a:p>
+            <a:p>
+              <a:r>
+                <a:rPr lang="en-US" sz="1600" b="1" dirty="0">
+                  <a:latin typeface="Courier New" pitchFamily="49" charset="0"/>
+                  <a:cs typeface="Courier New" pitchFamily="49" charset="0"/>
+                </a:rPr>
+                <a:t>  port in int a, </a:t>
+              </a:r>
+            </a:p>
+            <a:p>
+              <a:r>
+                <a:rPr lang="en-US" sz="1600" b="1" dirty="0">
+                  <a:latin typeface="Courier New" pitchFamily="49" charset="0"/>
+                  <a:cs typeface="Courier New" pitchFamily="49" charset="0"/>
+                </a:rPr>
+                <a:t>       out int b, </a:t>
+              </a:r>
+            </a:p>
+            <a:p>
+              <a:r>
+                <a:rPr lang="en-US" sz="1600" b="1" dirty="0">
+                  <a:latin typeface="Courier New" pitchFamily="49" charset="0"/>
+                  <a:cs typeface="Courier New" pitchFamily="49" charset="0"/>
+                </a:rPr>
+                <a:t>       out int c;</a:t>
+              </a:r>
+            </a:p>
+            <a:p>
+              <a:r>
+                <a:rPr lang="en-US" sz="1600" b="1" dirty="0">
+                  <a:latin typeface="Courier New" pitchFamily="49" charset="0"/>
+                  <a:cs typeface="Courier New" pitchFamily="49" charset="0"/>
+                </a:rPr>
+                <a:t>  </a:t>
+              </a:r>
+            </a:p>
+            <a:p>
+              <a:r>
+                <a:rPr lang="en-US" sz="1600" b="1" dirty="0">
+                  <a:latin typeface="Courier New" pitchFamily="49" charset="0"/>
+                  <a:cs typeface="Courier New" pitchFamily="49" charset="0"/>
+                </a:rPr>
+                <a:t>  G </a:t>
+              </a:r>
+              <a:r>
+                <a:rPr lang="en-US" sz="1600" b="1" dirty="0" err="1">
+                  <a:latin typeface="Courier New" pitchFamily="49" charset="0"/>
+                  <a:cs typeface="Courier New" pitchFamily="49" charset="0"/>
+                </a:rPr>
+                <a:t>g</a:t>
+              </a:r>
+              <a:r>
+                <a:rPr lang="en-US" sz="1600" b="1" dirty="0">
+                  <a:latin typeface="Courier New" pitchFamily="49" charset="0"/>
+                  <a:cs typeface="Courier New" pitchFamily="49" charset="0"/>
+                </a:rPr>
+                <a:t>;</a:t>
+              </a:r>
+            </a:p>
+            <a:p>
+              <a:r>
+                <a:rPr lang="en-US" sz="1600" b="1" dirty="0">
+                  <a:latin typeface="Courier New" pitchFamily="49" charset="0"/>
+                  <a:cs typeface="Courier New" pitchFamily="49" charset="0"/>
+                </a:rPr>
+                <a:t>  H </a:t>
+              </a:r>
+              <a:r>
+                <a:rPr lang="en-US" sz="1600" b="1" dirty="0" err="1">
+                  <a:latin typeface="Courier New" pitchFamily="49" charset="0"/>
+                  <a:cs typeface="Courier New" pitchFamily="49" charset="0"/>
+                </a:rPr>
+                <a:t>h</a:t>
+              </a:r>
+              <a:r>
+                <a:rPr lang="en-US" sz="1600" b="1" dirty="0">
+                  <a:latin typeface="Courier New" pitchFamily="49" charset="0"/>
+                  <a:cs typeface="Courier New" pitchFamily="49" charset="0"/>
+                </a:rPr>
+                <a:t>;</a:t>
+              </a:r>
+            </a:p>
+            <a:p>
+              <a:endParaRPr lang="en-US" sz="1600" b="1" dirty="0">
+                <a:latin typeface="Courier New" pitchFamily="49" charset="0"/>
+                <a:cs typeface="Courier New" pitchFamily="49" charset="0"/>
+              </a:endParaRPr>
+            </a:p>
+            <a:p>
+              <a:r>
+                <a:rPr lang="en-US" sz="1600" b="1" dirty="0">
+                  <a:latin typeface="Courier New" pitchFamily="49" charset="0"/>
+                  <a:cs typeface="Courier New" pitchFamily="49" charset="0"/>
+                </a:rPr>
+                <a:t>  a -&gt; </a:t>
+              </a:r>
+              <a:r>
+                <a:rPr lang="en-US" sz="1600" b="1" dirty="0" err="1">
+                  <a:latin typeface="Courier New" pitchFamily="49" charset="0"/>
+                  <a:cs typeface="Courier New" pitchFamily="49" charset="0"/>
+                </a:rPr>
+                <a:t>g.b</a:t>
+              </a:r>
+              <a:r>
+                <a:rPr lang="en-US" sz="1600" b="1" dirty="0">
+                  <a:latin typeface="Courier New" pitchFamily="49" charset="0"/>
+                  <a:cs typeface="Courier New" pitchFamily="49" charset="0"/>
+                </a:rPr>
+                <a:t>;</a:t>
+              </a:r>
+            </a:p>
+            <a:p>
+              <a:r>
+                <a:rPr lang="en-US" sz="1600" b="1" dirty="0">
+                  <a:latin typeface="Courier New" pitchFamily="49" charset="0"/>
+                  <a:cs typeface="Courier New" pitchFamily="49" charset="0"/>
+                </a:rPr>
+                <a:t>  </a:t>
+              </a:r>
+              <a:r>
+                <a:rPr lang="en-US" sz="1600" b="1" dirty="0" err="1">
+                  <a:latin typeface="Courier New" pitchFamily="49" charset="0"/>
+                  <a:cs typeface="Courier New" pitchFamily="49" charset="0"/>
+                </a:rPr>
+                <a:t>g.c</a:t>
+              </a:r>
+              <a:r>
+                <a:rPr lang="en-US" sz="1600" b="1" dirty="0">
+                  <a:latin typeface="Courier New" pitchFamily="49" charset="0"/>
+                  <a:cs typeface="Courier New" pitchFamily="49" charset="0"/>
+                </a:rPr>
+                <a:t> -&gt; b;</a:t>
+              </a:r>
+            </a:p>
+            <a:p>
+              <a:r>
+                <a:rPr lang="en-US" sz="1600" b="1" dirty="0">
+                  <a:latin typeface="Courier New" pitchFamily="49" charset="0"/>
+                  <a:cs typeface="Courier New" pitchFamily="49" charset="0"/>
+                </a:rPr>
+                <a:t>  </a:t>
+              </a:r>
+              <a:r>
+                <a:rPr lang="en-US" sz="1600" b="1" dirty="0" err="1">
+                  <a:latin typeface="Courier New" pitchFamily="49" charset="0"/>
+                  <a:cs typeface="Courier New" pitchFamily="49" charset="0"/>
+                </a:rPr>
+                <a:t>g.d</a:t>
+              </a:r>
+              <a:r>
+                <a:rPr lang="en-US" sz="1600" b="1" dirty="0">
+                  <a:latin typeface="Courier New" pitchFamily="49" charset="0"/>
+                  <a:cs typeface="Courier New" pitchFamily="49" charset="0"/>
+                </a:rPr>
+                <a:t> -&gt; </a:t>
+              </a:r>
+              <a:r>
+                <a:rPr lang="en-US" sz="1600" b="1" dirty="0" err="1">
+                  <a:latin typeface="Courier New" pitchFamily="49" charset="0"/>
+                  <a:cs typeface="Courier New" pitchFamily="49" charset="0"/>
+                </a:rPr>
+                <a:t>h.e</a:t>
+              </a:r>
+              <a:r>
+                <a:rPr lang="en-US" sz="1600" b="1" dirty="0">
+                  <a:latin typeface="Courier New" pitchFamily="49" charset="0"/>
+                  <a:cs typeface="Courier New" pitchFamily="49" charset="0"/>
+                </a:rPr>
+                <a:t>;</a:t>
+              </a:r>
+            </a:p>
+            <a:p>
+              <a:r>
+                <a:rPr lang="en-US" sz="1600" b="1" dirty="0">
+                  <a:latin typeface="Courier New" pitchFamily="49" charset="0"/>
+                  <a:cs typeface="Courier New" pitchFamily="49" charset="0"/>
+                </a:rPr>
+                <a:t>  </a:t>
+              </a:r>
+              <a:r>
+                <a:rPr lang="en-US" sz="1600" b="1" dirty="0" err="1">
+                  <a:latin typeface="Courier New" pitchFamily="49" charset="0"/>
+                  <a:cs typeface="Courier New" pitchFamily="49" charset="0"/>
+                </a:rPr>
+                <a:t>h.f</a:t>
+              </a:r>
+              <a:r>
+                <a:rPr lang="en-US" sz="1600" b="1" dirty="0">
+                  <a:latin typeface="Courier New" pitchFamily="49" charset="0"/>
+                  <a:cs typeface="Courier New" pitchFamily="49" charset="0"/>
+                </a:rPr>
+                <a:t> -&gt; c;</a:t>
+              </a:r>
+            </a:p>
+            <a:p>
+              <a:r>
+                <a:rPr lang="en-US" sz="1600" b="1" dirty="0">
+                  <a:latin typeface="Courier New" pitchFamily="49" charset="0"/>
+                  <a:cs typeface="Courier New" pitchFamily="49" charset="0"/>
+                </a:rPr>
+                <a:t>}	</a:t>
+              </a:r>
+            </a:p>
+          </p:txBody>
+        </p:sp>
+        <p:sp>
+          <p:nvSpPr>
+            <p:cNvPr id="53" name="Text Box 6">
+              <a:extLst>
+                <a:ext uri="{FF2B5EF4-FFF2-40B4-BE49-F238E27FC236}">
+                  <a16:creationId xmlns:a16="http://schemas.microsoft.com/office/drawing/2014/main" id="{E21A556D-336B-828C-1DF1-428F97615954}"/>
+                </a:ext>
+              </a:extLst>
+            </p:cNvPr>
+            <p:cNvSpPr txBox="1">
+              <a:spLocks noChangeArrowheads="1"/>
+            </p:cNvSpPr>
+            <p:nvPr/>
+          </p:nvSpPr>
+          <p:spPr bwMode="auto">
+            <a:xfrm>
+              <a:off x="1247387" y="2501638"/>
+              <a:ext cx="503238" cy="3293209"/>
+            </a:xfrm>
+            <a:prstGeom prst="rect">
+              <a:avLst/>
+            </a:prstGeom>
+            <a:noFill/>
+            <a:ln w="9525">
+              <a:noFill/>
+              <a:miter lim="800000"/>
+              <a:headEnd/>
+              <a:tailEnd/>
+            </a:ln>
+            <a:effectLst/>
+          </p:spPr>
+          <p:txBody>
+            <a:bodyPr>
+              <a:spAutoFit/>
+            </a:bodyPr>
+            <a:lstStyle/>
+            <a:p>
+              <a:pPr algn="r"/>
+              <a:r>
+                <a:rPr lang="en-US" sz="1600" dirty="0"/>
+                <a:t>1</a:t>
+              </a:r>
+            </a:p>
+            <a:p>
+              <a:pPr algn="r"/>
+              <a:r>
+                <a:rPr lang="en-US" sz="1600" dirty="0"/>
+                <a:t>2</a:t>
+              </a:r>
+            </a:p>
+            <a:p>
+              <a:pPr algn="r"/>
+              <a:r>
+                <a:rPr lang="en-US" sz="1600" dirty="0"/>
+                <a:t>3</a:t>
+              </a:r>
+            </a:p>
+            <a:p>
+              <a:pPr algn="r"/>
+              <a:r>
+                <a:rPr lang="en-US" sz="1600" dirty="0"/>
+                <a:t>4</a:t>
+              </a:r>
+            </a:p>
+            <a:p>
+              <a:pPr algn="r"/>
+              <a:r>
+                <a:rPr lang="en-US" sz="1600" dirty="0"/>
+                <a:t>5</a:t>
+              </a:r>
+            </a:p>
+            <a:p>
+              <a:pPr algn="r"/>
+              <a:r>
+                <a:rPr lang="en-US" sz="1600" dirty="0"/>
+                <a:t>6</a:t>
+              </a:r>
+            </a:p>
+            <a:p>
+              <a:pPr algn="r"/>
+              <a:r>
+                <a:rPr lang="en-US" sz="1600" dirty="0"/>
+                <a:t>7</a:t>
+              </a:r>
+            </a:p>
+            <a:p>
+              <a:pPr algn="r"/>
+              <a:r>
+                <a:rPr lang="en-US" sz="1600" dirty="0"/>
+                <a:t>8</a:t>
+              </a:r>
+            </a:p>
+            <a:p>
+              <a:pPr algn="r"/>
+              <a:r>
+                <a:rPr lang="en-US" sz="1600" dirty="0"/>
+                <a:t>9</a:t>
+              </a:r>
+            </a:p>
+            <a:p>
+              <a:pPr algn="r"/>
+              <a:r>
+                <a:rPr lang="en-US" sz="1600" dirty="0"/>
+                <a:t>10</a:t>
+              </a:r>
+            </a:p>
+            <a:p>
+              <a:pPr algn="r"/>
+              <a:r>
+                <a:rPr lang="en-US" sz="1600" dirty="0"/>
+                <a:t>11</a:t>
+              </a:r>
+            </a:p>
+            <a:p>
+              <a:pPr algn="r"/>
+              <a:r>
+                <a:rPr lang="en-US" sz="1600" dirty="0"/>
+                <a:t>12</a:t>
+              </a:r>
+            </a:p>
+            <a:p>
+              <a:pPr algn="r"/>
+              <a:r>
+                <a:rPr lang="en-US" sz="1600" dirty="0"/>
+                <a:t>13</a:t>
+              </a:r>
+            </a:p>
+          </p:txBody>
+        </p:sp>
+        <p:sp>
+          <p:nvSpPr>
+            <p:cNvPr id="54" name="AutoShape 40">
+              <a:extLst>
+                <a:ext uri="{FF2B5EF4-FFF2-40B4-BE49-F238E27FC236}">
+                  <a16:creationId xmlns:a16="http://schemas.microsoft.com/office/drawing/2014/main" id="{2815FF07-AC22-2D08-F1F4-D65233C87202}"/>
+                </a:ext>
+              </a:extLst>
+            </p:cNvPr>
+            <p:cNvSpPr>
+              <a:spLocks noChangeArrowheads="1"/>
+            </p:cNvSpPr>
+            <p:nvPr/>
+          </p:nvSpPr>
+          <p:spPr bwMode="auto">
+            <a:xfrm flipV="1">
+              <a:off x="4252361" y="2478840"/>
+              <a:ext cx="609600" cy="304800"/>
+            </a:xfrm>
+            <a:prstGeom prst="foldedCorner">
+              <a:avLst>
+                <a:gd name="adj" fmla="val 27606"/>
+              </a:avLst>
+            </a:prstGeom>
+            <a:solidFill>
+              <a:srgbClr val="FFFFFF"/>
+            </a:solidFill>
+            <a:ln w="9525">
+              <a:solidFill>
+                <a:srgbClr val="000000"/>
+              </a:solidFill>
+              <a:round/>
+              <a:headEnd/>
+              <a:tailEnd/>
+            </a:ln>
+          </p:spPr>
+          <p:txBody>
+            <a:bodyPr rot="10800000" wrap="none" anchor="ctr" anchorCtr="1"/>
+            <a:lstStyle/>
+            <a:p>
+              <a:pPr marL="0" marR="0" lvl="0" indent="0" algn="l" defTabSz="914400" rtl="0" eaLnBrk="0" fontAlgn="auto" latinLnBrk="0" hangingPunct="0">
+                <a:lnSpc>
+                  <a:spcPct val="70000"/>
+                </a:lnSpc>
+                <a:spcBef>
+                  <a:spcPts val="0"/>
+                </a:spcBef>
+                <a:spcAft>
+                  <a:spcPts val="0"/>
+                </a:spcAft>
+                <a:buClrTx/>
+                <a:buSzTx/>
+                <a:buFontTx/>
+                <a:buNone/>
+                <a:tabLst/>
+                <a:defRPr/>
+              </a:pPr>
+              <a:r>
+                <a:rPr kumimoji="0" lang="en-US" altLang="de-DE" sz="1600" b="0" i="0" u="none" strike="noStrike" kern="1200" cap="none" spc="0" normalizeH="0" baseline="0" dirty="0">
+                  <a:ln>
+                    <a:noFill/>
+                  </a:ln>
+                  <a:solidFill>
+                    <a:srgbClr val="000000"/>
+                  </a:solidFill>
+                  <a:effectLst/>
+                  <a:uLnTx/>
+                  <a:uFillTx/>
+                  <a:latin typeface="Arial"/>
+                  <a:ea typeface="+mn-ea"/>
+                  <a:cs typeface="+mn-cs"/>
+                </a:rPr>
+                <a:t>MA</a:t>
+              </a:r>
+            </a:p>
+          </p:txBody>
+        </p:sp>
+      </p:grpSp>
+      <p:grpSp>
+        <p:nvGrpSpPr>
+          <p:cNvPr id="4" name="Gruppieren 50">
+            <a:extLst>
+              <a:ext uri="{FF2B5EF4-FFF2-40B4-BE49-F238E27FC236}">
+                <a16:creationId xmlns:a16="http://schemas.microsoft.com/office/drawing/2014/main" id="{9F677F1A-6514-435A-8C26-C14317F3C59C}"/>
+              </a:ext>
+            </a:extLst>
+          </p:cNvPr>
+          <p:cNvGrpSpPr/>
+          <p:nvPr/>
+        </p:nvGrpSpPr>
+        <p:grpSpPr>
+          <a:xfrm>
+            <a:off x="3054648" y="945647"/>
+            <a:ext cx="3779154" cy="3321304"/>
+            <a:chOff x="1247387" y="2473543"/>
+            <a:chExt cx="4543867" cy="3321304"/>
+          </a:xfrm>
+        </p:grpSpPr>
+        <p:sp>
+          <p:nvSpPr>
+            <p:cNvPr id="23" name="Text Box 3">
+              <a:extLst>
+                <a:ext uri="{FF2B5EF4-FFF2-40B4-BE49-F238E27FC236}">
+                  <a16:creationId xmlns:a16="http://schemas.microsoft.com/office/drawing/2014/main" id="{69C562A6-D839-2FC6-0230-774590A29AB8}"/>
+                </a:ext>
+              </a:extLst>
+            </p:cNvPr>
+            <p:cNvSpPr txBox="1">
+              <a:spLocks noChangeArrowheads="1"/>
+            </p:cNvSpPr>
+            <p:nvPr/>
+          </p:nvSpPr>
+          <p:spPr bwMode="auto">
+            <a:xfrm>
+              <a:off x="1763689" y="2478840"/>
+              <a:ext cx="4027565" cy="3293209"/>
+            </a:xfrm>
+            <a:prstGeom prst="rect">
+              <a:avLst/>
+            </a:prstGeom>
+            <a:noFill/>
+            <a:ln w="9525">
+              <a:solidFill>
+                <a:schemeClr val="tx1"/>
+              </a:solidFill>
+              <a:miter lim="800000"/>
+              <a:headEnd/>
+              <a:tailEnd/>
+            </a:ln>
+            <a:effectLst/>
+          </p:spPr>
+          <p:txBody>
+            <a:bodyPr wrap="square">
+              <a:spAutoFit/>
+            </a:bodyPr>
+            <a:lstStyle/>
+            <a:p>
+              <a:r>
+                <a:rPr lang="en-US" sz="1600" b="1" dirty="0">
+                  <a:latin typeface="Courier New" pitchFamily="49" charset="0"/>
+                  <a:cs typeface="Courier New" pitchFamily="49" charset="0"/>
+                </a:rPr>
+                <a:t>part def F {</a:t>
+              </a:r>
+            </a:p>
+            <a:p>
+              <a:r>
+                <a:rPr lang="en-US" sz="1600" b="1" dirty="0">
+                  <a:latin typeface="Courier New" pitchFamily="49" charset="0"/>
+                  <a:cs typeface="Courier New" pitchFamily="49" charset="0"/>
+                </a:rPr>
+                <a:t>  port a : </a:t>
+              </a:r>
+              <a:r>
+                <a:rPr lang="en-US" sz="1600" b="1" dirty="0" err="1">
+                  <a:latin typeface="Courier New" pitchFamily="49" charset="0"/>
+                  <a:cs typeface="Courier New" pitchFamily="49" charset="0"/>
+                </a:rPr>
+                <a:t>IntPort</a:t>
+              </a:r>
+              <a:r>
+                <a:rPr lang="en-US" sz="1600" b="1" dirty="0">
+                  <a:latin typeface="Courier New" pitchFamily="49" charset="0"/>
+                  <a:cs typeface="Courier New" pitchFamily="49" charset="0"/>
+                </a:rPr>
+                <a:t>;</a:t>
+              </a:r>
+            </a:p>
+            <a:p>
+              <a:r>
+                <a:rPr lang="en-US" sz="1600" b="1" dirty="0">
+                  <a:latin typeface="Courier New" pitchFamily="49" charset="0"/>
+                  <a:cs typeface="Courier New" pitchFamily="49" charset="0"/>
+                </a:rPr>
+                <a:t>  port b : ~</a:t>
+              </a:r>
+              <a:r>
+                <a:rPr lang="en-US" sz="1600" b="1" dirty="0" err="1">
+                  <a:latin typeface="Courier New" pitchFamily="49" charset="0"/>
+                  <a:cs typeface="Courier New" pitchFamily="49" charset="0"/>
+                </a:rPr>
+                <a:t>IntPort</a:t>
+              </a:r>
+              <a:r>
+                <a:rPr lang="en-US" sz="1600" b="1" dirty="0">
+                  <a:latin typeface="Courier New" pitchFamily="49" charset="0"/>
+                  <a:cs typeface="Courier New" pitchFamily="49" charset="0"/>
+                </a:rPr>
+                <a:t>;</a:t>
+              </a:r>
+            </a:p>
+            <a:p>
+              <a:r>
+                <a:rPr lang="en-US" sz="1600" b="1" dirty="0">
+                  <a:latin typeface="Courier New" pitchFamily="49" charset="0"/>
+                  <a:cs typeface="Courier New" pitchFamily="49" charset="0"/>
+                </a:rPr>
+                <a:t>  port c : ~</a:t>
+              </a:r>
+              <a:r>
+                <a:rPr lang="en-US" sz="1600" b="1" dirty="0" err="1">
+                  <a:latin typeface="Courier New" pitchFamily="49" charset="0"/>
+                  <a:cs typeface="Courier New" pitchFamily="49" charset="0"/>
+                </a:rPr>
+                <a:t>IntPort</a:t>
+              </a:r>
+              <a:r>
+                <a:rPr lang="en-US" sz="1600" b="1" dirty="0">
+                  <a:latin typeface="Courier New" pitchFamily="49" charset="0"/>
+                  <a:cs typeface="Courier New" pitchFamily="49" charset="0"/>
+                </a:rPr>
+                <a:t>;</a:t>
+              </a:r>
+            </a:p>
+            <a:p>
+              <a:r>
+                <a:rPr lang="en-US" sz="1600" b="1" dirty="0">
+                  <a:latin typeface="Courier New" pitchFamily="49" charset="0"/>
+                  <a:cs typeface="Courier New" pitchFamily="49" charset="0"/>
+                </a:rPr>
+                <a:t>  </a:t>
+              </a:r>
+            </a:p>
+            <a:p>
+              <a:r>
+                <a:rPr lang="en-US" sz="1600" b="1" dirty="0">
+                  <a:latin typeface="Courier New" pitchFamily="49" charset="0"/>
+                  <a:cs typeface="Courier New" pitchFamily="49" charset="0"/>
+                </a:rPr>
+                <a:t>  part g : G;</a:t>
+              </a:r>
+            </a:p>
+            <a:p>
+              <a:r>
+                <a:rPr lang="en-US" sz="1600" b="1" dirty="0">
+                  <a:latin typeface="Courier New" pitchFamily="49" charset="0"/>
+                  <a:cs typeface="Courier New" pitchFamily="49" charset="0"/>
+                </a:rPr>
+                <a:t>  part h : H;</a:t>
+              </a:r>
+            </a:p>
+            <a:p>
+              <a:endParaRPr lang="en-US" sz="1600" b="1" dirty="0">
+                <a:latin typeface="Courier New" pitchFamily="49" charset="0"/>
+                <a:cs typeface="Courier New" pitchFamily="49" charset="0"/>
+              </a:endParaRPr>
+            </a:p>
+            <a:p>
+              <a:r>
+                <a:rPr lang="en-US" sz="1600" b="1" dirty="0">
+                  <a:latin typeface="Courier New" pitchFamily="49" charset="0"/>
+                  <a:cs typeface="Courier New" pitchFamily="49" charset="0"/>
+                </a:rPr>
+                <a:t>  connect a to </a:t>
+              </a:r>
+              <a:r>
+                <a:rPr lang="en-US" sz="1600" b="1" dirty="0" err="1">
+                  <a:latin typeface="Courier New" pitchFamily="49" charset="0"/>
+                  <a:cs typeface="Courier New" pitchFamily="49" charset="0"/>
+                </a:rPr>
+                <a:t>g.b</a:t>
+              </a:r>
+              <a:r>
+                <a:rPr lang="en-US" sz="1600" b="1" dirty="0">
+                  <a:latin typeface="Courier New" pitchFamily="49" charset="0"/>
+                  <a:cs typeface="Courier New" pitchFamily="49" charset="0"/>
+                </a:rPr>
+                <a:t>;</a:t>
+              </a:r>
+            </a:p>
+            <a:p>
+              <a:r>
+                <a:rPr lang="en-US" sz="1600" b="1" dirty="0">
+                  <a:latin typeface="Courier New" pitchFamily="49" charset="0"/>
+                  <a:cs typeface="Courier New" pitchFamily="49" charset="0"/>
+                </a:rPr>
+                <a:t>  connect </a:t>
+              </a:r>
+              <a:r>
+                <a:rPr lang="en-US" sz="1600" b="1" dirty="0" err="1">
+                  <a:latin typeface="Courier New" pitchFamily="49" charset="0"/>
+                  <a:cs typeface="Courier New" pitchFamily="49" charset="0"/>
+                </a:rPr>
+                <a:t>g.c</a:t>
+              </a:r>
+              <a:r>
+                <a:rPr lang="en-US" sz="1600" b="1" dirty="0">
+                  <a:latin typeface="Courier New" pitchFamily="49" charset="0"/>
+                  <a:cs typeface="Courier New" pitchFamily="49" charset="0"/>
+                </a:rPr>
+                <a:t> to b;</a:t>
+              </a:r>
+            </a:p>
+            <a:p>
+              <a:r>
+                <a:rPr lang="en-US" sz="1600" b="1" dirty="0">
+                  <a:latin typeface="Courier New" pitchFamily="49" charset="0"/>
+                  <a:cs typeface="Courier New" pitchFamily="49" charset="0"/>
+                </a:rPr>
+                <a:t>  connect </a:t>
+              </a:r>
+              <a:r>
+                <a:rPr lang="en-US" sz="1600" b="1" dirty="0" err="1">
+                  <a:latin typeface="Courier New" pitchFamily="49" charset="0"/>
+                  <a:cs typeface="Courier New" pitchFamily="49" charset="0"/>
+                </a:rPr>
+                <a:t>g.d</a:t>
+              </a:r>
+              <a:r>
+                <a:rPr lang="en-US" sz="1600" b="1" dirty="0">
+                  <a:latin typeface="Courier New" pitchFamily="49" charset="0"/>
+                  <a:cs typeface="Courier New" pitchFamily="49" charset="0"/>
+                </a:rPr>
+                <a:t> to </a:t>
+              </a:r>
+              <a:r>
+                <a:rPr lang="en-US" sz="1600" b="1" dirty="0" err="1">
+                  <a:latin typeface="Courier New" pitchFamily="49" charset="0"/>
+                  <a:cs typeface="Courier New" pitchFamily="49" charset="0"/>
+                </a:rPr>
+                <a:t>h.e</a:t>
+              </a:r>
+              <a:r>
+                <a:rPr lang="en-US" sz="1600" b="1" dirty="0">
+                  <a:latin typeface="Courier New" pitchFamily="49" charset="0"/>
+                  <a:cs typeface="Courier New" pitchFamily="49" charset="0"/>
+                </a:rPr>
+                <a:t>;</a:t>
+              </a:r>
+            </a:p>
+            <a:p>
+              <a:r>
+                <a:rPr lang="en-US" sz="1600" b="1" dirty="0">
+                  <a:latin typeface="Courier New" pitchFamily="49" charset="0"/>
+                  <a:cs typeface="Courier New" pitchFamily="49" charset="0"/>
+                </a:rPr>
+                <a:t>  connect </a:t>
+              </a:r>
+              <a:r>
+                <a:rPr lang="en-US" sz="1600" b="1" dirty="0" err="1">
+                  <a:latin typeface="Courier New" pitchFamily="49" charset="0"/>
+                  <a:cs typeface="Courier New" pitchFamily="49" charset="0"/>
+                </a:rPr>
+                <a:t>h.f</a:t>
+              </a:r>
+              <a:r>
+                <a:rPr lang="en-US" sz="1600" b="1" dirty="0">
+                  <a:latin typeface="Courier New" pitchFamily="49" charset="0"/>
+                  <a:cs typeface="Courier New" pitchFamily="49" charset="0"/>
+                </a:rPr>
+                <a:t> to c;</a:t>
+              </a:r>
+            </a:p>
+            <a:p>
+              <a:r>
+                <a:rPr lang="en-US" sz="1600" b="1" dirty="0">
+                  <a:latin typeface="Courier New" pitchFamily="49" charset="0"/>
+                  <a:cs typeface="Courier New" pitchFamily="49" charset="0"/>
+                </a:rPr>
+                <a:t>}	</a:t>
+              </a:r>
+            </a:p>
+          </p:txBody>
+        </p:sp>
+        <p:sp>
+          <p:nvSpPr>
+            <p:cNvPr id="24" name="Text Box 6">
+              <a:extLst>
+                <a:ext uri="{FF2B5EF4-FFF2-40B4-BE49-F238E27FC236}">
+                  <a16:creationId xmlns:a16="http://schemas.microsoft.com/office/drawing/2014/main" id="{2655803D-A061-2210-7E9A-F797C860EDCB}"/>
+                </a:ext>
+              </a:extLst>
+            </p:cNvPr>
+            <p:cNvSpPr txBox="1">
+              <a:spLocks noChangeArrowheads="1"/>
+            </p:cNvSpPr>
+            <p:nvPr/>
+          </p:nvSpPr>
+          <p:spPr bwMode="auto">
+            <a:xfrm>
+              <a:off x="1247387" y="2501638"/>
+              <a:ext cx="503238" cy="3293209"/>
+            </a:xfrm>
+            <a:prstGeom prst="rect">
+              <a:avLst/>
+            </a:prstGeom>
+            <a:noFill/>
+            <a:ln w="9525">
+              <a:noFill/>
+              <a:miter lim="800000"/>
+              <a:headEnd/>
+              <a:tailEnd/>
+            </a:ln>
+            <a:effectLst/>
+          </p:spPr>
+          <p:txBody>
+            <a:bodyPr>
+              <a:spAutoFit/>
+            </a:bodyPr>
+            <a:lstStyle/>
+            <a:p>
+              <a:pPr algn="r"/>
+              <a:r>
+                <a:rPr lang="en-US" sz="1600" dirty="0"/>
+                <a:t>1</a:t>
+              </a:r>
+            </a:p>
+            <a:p>
+              <a:pPr algn="r"/>
+              <a:r>
+                <a:rPr lang="en-US" sz="1600" dirty="0"/>
+                <a:t>2</a:t>
+              </a:r>
+            </a:p>
+            <a:p>
+              <a:pPr algn="r"/>
+              <a:r>
+                <a:rPr lang="en-US" sz="1600" dirty="0"/>
+                <a:t>3</a:t>
+              </a:r>
+            </a:p>
+            <a:p>
+              <a:pPr algn="r"/>
+              <a:r>
+                <a:rPr lang="en-US" sz="1600" dirty="0"/>
+                <a:t>4</a:t>
+              </a:r>
+            </a:p>
+            <a:p>
+              <a:pPr algn="r"/>
+              <a:r>
+                <a:rPr lang="en-US" sz="1600" dirty="0"/>
+                <a:t>5</a:t>
+              </a:r>
+            </a:p>
+            <a:p>
+              <a:pPr algn="r"/>
+              <a:r>
+                <a:rPr lang="en-US" sz="1600" dirty="0"/>
+                <a:t>6</a:t>
+              </a:r>
+            </a:p>
+            <a:p>
+              <a:pPr algn="r"/>
+              <a:r>
+                <a:rPr lang="en-US" sz="1600" dirty="0"/>
+                <a:t>7</a:t>
+              </a:r>
+            </a:p>
+            <a:p>
+              <a:pPr algn="r"/>
+              <a:r>
+                <a:rPr lang="en-US" sz="1600" dirty="0"/>
+                <a:t>8</a:t>
+              </a:r>
+            </a:p>
+            <a:p>
+              <a:pPr algn="r"/>
+              <a:r>
+                <a:rPr lang="en-US" sz="1600" dirty="0"/>
+                <a:t>9</a:t>
+              </a:r>
+            </a:p>
+            <a:p>
+              <a:pPr algn="r"/>
+              <a:r>
+                <a:rPr lang="en-US" sz="1600" dirty="0"/>
+                <a:t>10</a:t>
+              </a:r>
+            </a:p>
+            <a:p>
+              <a:pPr algn="r"/>
+              <a:r>
+                <a:rPr lang="en-US" sz="1600" dirty="0"/>
+                <a:t>11</a:t>
+              </a:r>
+            </a:p>
+            <a:p>
+              <a:pPr algn="r"/>
+              <a:r>
+                <a:rPr lang="en-US" sz="1600" dirty="0"/>
+                <a:t>12</a:t>
+              </a:r>
+            </a:p>
+            <a:p>
+              <a:pPr algn="r"/>
+              <a:r>
+                <a:rPr lang="en-US" sz="1600" dirty="0"/>
+                <a:t>13</a:t>
+              </a:r>
+            </a:p>
+          </p:txBody>
+        </p:sp>
+        <p:sp>
+          <p:nvSpPr>
+            <p:cNvPr id="25" name="AutoShape 40">
+              <a:extLst>
+                <a:ext uri="{FF2B5EF4-FFF2-40B4-BE49-F238E27FC236}">
+                  <a16:creationId xmlns:a16="http://schemas.microsoft.com/office/drawing/2014/main" id="{53D4B85A-D474-D716-2BD0-9D3395D7CD40}"/>
+                </a:ext>
+              </a:extLst>
+            </p:cNvPr>
+            <p:cNvSpPr>
+              <a:spLocks noChangeArrowheads="1"/>
+            </p:cNvSpPr>
+            <p:nvPr/>
+          </p:nvSpPr>
+          <p:spPr bwMode="auto">
+            <a:xfrm flipV="1">
+              <a:off x="4587085" y="2473543"/>
+              <a:ext cx="1204169" cy="304800"/>
+            </a:xfrm>
+            <a:prstGeom prst="foldedCorner">
+              <a:avLst>
+                <a:gd name="adj" fmla="val 27606"/>
+              </a:avLst>
+            </a:prstGeom>
+            <a:solidFill>
+              <a:srgbClr val="FFFFFF"/>
+            </a:solidFill>
+            <a:ln w="9525">
+              <a:solidFill>
+                <a:srgbClr val="000000"/>
+              </a:solidFill>
+              <a:round/>
+              <a:headEnd/>
+              <a:tailEnd/>
+            </a:ln>
+          </p:spPr>
+          <p:txBody>
+            <a:bodyPr rot="10800000" wrap="none" anchor="ctr" anchorCtr="1"/>
+            <a:lstStyle/>
+            <a:p>
+              <a:pPr marL="0" marR="0" lvl="0" indent="0" algn="l" defTabSz="914400" rtl="0" eaLnBrk="0" fontAlgn="auto" latinLnBrk="0" hangingPunct="0">
+                <a:lnSpc>
+                  <a:spcPct val="70000"/>
+                </a:lnSpc>
+                <a:spcBef>
+                  <a:spcPts val="0"/>
+                </a:spcBef>
+                <a:spcAft>
+                  <a:spcPts val="0"/>
+                </a:spcAft>
+                <a:buClrTx/>
+                <a:buSzTx/>
+                <a:buFontTx/>
+                <a:buNone/>
+                <a:tabLst/>
+                <a:defRPr/>
+              </a:pPr>
+              <a:r>
+                <a:rPr kumimoji="0" lang="en-US" altLang="de-DE" sz="1600" b="0" i="0" u="none" strike="noStrike" kern="1200" cap="none" spc="0" normalizeH="0" baseline="0" dirty="0" err="1">
+                  <a:ln>
+                    <a:noFill/>
+                  </a:ln>
+                  <a:solidFill>
+                    <a:srgbClr val="000000"/>
+                  </a:solidFill>
+                  <a:effectLst/>
+                  <a:uLnTx/>
+                  <a:uFillTx/>
+                  <a:latin typeface="Arial"/>
+                  <a:ea typeface="+mn-ea"/>
+                  <a:cs typeface="+mn-cs"/>
+                </a:rPr>
+                <a:t>SysML</a:t>
+              </a:r>
+              <a:r>
+                <a:rPr kumimoji="0" lang="en-US" altLang="de-DE" sz="1600" b="0" i="0" u="none" strike="noStrike" kern="1200" cap="none" spc="0" normalizeH="0" baseline="0" dirty="0">
+                  <a:ln>
+                    <a:noFill/>
+                  </a:ln>
+                  <a:solidFill>
+                    <a:srgbClr val="000000"/>
+                  </a:solidFill>
+                  <a:effectLst/>
+                  <a:uLnTx/>
+                  <a:uFillTx/>
+                  <a:latin typeface="Arial"/>
+                  <a:ea typeface="+mn-ea"/>
+                  <a:cs typeface="+mn-cs"/>
+                </a:rPr>
+                <a:t> v2</a:t>
+              </a:r>
+            </a:p>
+          </p:txBody>
+        </p:sp>
+      </p:grpSp>
+      <p:grpSp>
+        <p:nvGrpSpPr>
+          <p:cNvPr id="26" name="Gruppieren 31">
+            <a:extLst>
+              <a:ext uri="{FF2B5EF4-FFF2-40B4-BE49-F238E27FC236}">
+                <a16:creationId xmlns:a16="http://schemas.microsoft.com/office/drawing/2014/main" id="{94B703BA-5DD7-658B-9BE6-49FBDE251CD1}"/>
+              </a:ext>
+            </a:extLst>
+          </p:cNvPr>
+          <p:cNvGrpSpPr/>
+          <p:nvPr/>
+        </p:nvGrpSpPr>
+        <p:grpSpPr>
+          <a:xfrm>
+            <a:off x="7392074" y="1355108"/>
+            <a:ext cx="3839671" cy="412750"/>
+            <a:chOff x="4353342" y="1861556"/>
+            <a:chExt cx="3281668" cy="412750"/>
+          </a:xfrm>
+        </p:grpSpPr>
+        <p:sp>
+          <p:nvSpPr>
+            <p:cNvPr id="27" name="Text Box 82">
+              <a:extLst>
+                <a:ext uri="{FF2B5EF4-FFF2-40B4-BE49-F238E27FC236}">
+                  <a16:creationId xmlns:a16="http://schemas.microsoft.com/office/drawing/2014/main" id="{4F1D71A5-884A-AFF8-3D62-4D6358F376C0}"/>
+                </a:ext>
+              </a:extLst>
+            </p:cNvPr>
+            <p:cNvSpPr txBox="1">
+              <a:spLocks noChangeArrowheads="1"/>
+            </p:cNvSpPr>
+            <p:nvPr/>
+          </p:nvSpPr>
+          <p:spPr bwMode="auto">
+            <a:xfrm>
+              <a:off x="5530278" y="1899656"/>
+              <a:ext cx="927796" cy="338554"/>
+            </a:xfrm>
+            <a:prstGeom prst="rect">
+              <a:avLst/>
+            </a:prstGeom>
+            <a:noFill/>
+            <a:ln w="9525">
+              <a:noFill/>
+              <a:miter lim="800000"/>
+              <a:headEnd/>
+              <a:tailEnd/>
+            </a:ln>
+          </p:spPr>
+          <p:txBody>
+            <a:bodyPr wrap="none">
+              <a:spAutoFit/>
+            </a:bodyPr>
+            <a:lstStyle/>
+            <a:p>
+              <a:pPr marL="0" marR="0" lvl="0" indent="0" algn="ctr" defTabSz="914400" eaLnBrk="0" fontAlgn="auto" latinLnBrk="0" hangingPunct="0">
+                <a:lnSpc>
+                  <a:spcPct val="100000"/>
+                </a:lnSpc>
+                <a:spcBef>
+                  <a:spcPts val="0"/>
+                </a:spcBef>
+                <a:spcAft>
+                  <a:spcPts val="0"/>
+                </a:spcAft>
+                <a:buClrTx/>
+                <a:buSzTx/>
+                <a:buFontTx/>
+                <a:buNone/>
+                <a:tabLst/>
+                <a:defRPr/>
+              </a:pPr>
+              <a:r>
+                <a:rPr lang="en-US" altLang="de-DE" sz="1600" u="sng" kern="0" dirty="0">
+                  <a:solidFill>
+                    <a:prstClr val="black"/>
+                  </a:solidFill>
+                </a:rPr>
+                <a:t>f</a:t>
+              </a:r>
+              <a:r>
+                <a:rPr kumimoji="0" lang="en-US" altLang="de-DE" sz="1600" b="0" i="0" u="sng" strike="noStrike" kern="0" cap="none" spc="0" normalizeH="0" baseline="0" noProof="0" dirty="0">
+                  <a:ln>
+                    <a:noFill/>
+                  </a:ln>
+                  <a:solidFill>
+                    <a:prstClr val="black"/>
+                  </a:solidFill>
+                  <a:effectLst/>
+                  <a:uLnTx/>
+                  <a:uFillTx/>
+                  <a:latin typeface="Arial" panose="020B0604020202020204" pitchFamily="34" charset="0"/>
+                  <a:ea typeface="ＭＳ Ｐゴシック" panose="020B0600070205080204" pitchFamily="34" charset="-128"/>
+                </a:rPr>
+                <a:t>:Function</a:t>
+              </a:r>
+            </a:p>
+          </p:txBody>
+        </p:sp>
+        <p:sp>
+          <p:nvSpPr>
+            <p:cNvPr id="29" name="Rectangle 83">
+              <a:extLst>
+                <a:ext uri="{FF2B5EF4-FFF2-40B4-BE49-F238E27FC236}">
+                  <a16:creationId xmlns:a16="http://schemas.microsoft.com/office/drawing/2014/main" id="{71B837E4-8AB8-E631-1E2A-EB73BE43CCAB}"/>
+                </a:ext>
+              </a:extLst>
+            </p:cNvPr>
+            <p:cNvSpPr>
+              <a:spLocks noChangeArrowheads="1"/>
+            </p:cNvSpPr>
+            <p:nvPr/>
+          </p:nvSpPr>
+          <p:spPr bwMode="auto">
+            <a:xfrm>
+              <a:off x="4353342" y="1861556"/>
+              <a:ext cx="3281668" cy="412750"/>
+            </a:xfrm>
+            <a:prstGeom prst="rect">
+              <a:avLst/>
+            </a:prstGeom>
+            <a:noFill/>
+            <a:ln w="9525">
+              <a:solidFill>
+                <a:sysClr val="windowText" lastClr="000000"/>
+              </a:solidFill>
+              <a:miter lim="800000"/>
+              <a:headEnd/>
+              <a:tailEnd/>
+            </a:ln>
+          </p:spPr>
+          <p:txBody>
+            <a:bodyPr wrap="none" anchor="ctr"/>
+            <a:lstStyle/>
+            <a:p>
+              <a:pPr marL="0" marR="0" lvl="0" indent="0" defTabSz="914400" eaLnBrk="0" fontAlgn="auto" latinLnBrk="0" hangingPunct="0">
+                <a:lnSpc>
+                  <a:spcPct val="100000"/>
+                </a:lnSpc>
+                <a:spcBef>
+                  <a:spcPts val="0"/>
+                </a:spcBef>
+                <a:spcAft>
+                  <a:spcPts val="0"/>
+                </a:spcAft>
+                <a:buClrTx/>
+                <a:buSzTx/>
+                <a:buFontTx/>
+                <a:buNone/>
+                <a:tabLst/>
+                <a:defRPr/>
+              </a:pPr>
+              <a:endParaRPr kumimoji="0" lang="en-US" sz="1800" b="0" i="0" u="none" strike="noStrike" kern="0" cap="none" spc="0" normalizeH="0" baseline="0" noProof="0" dirty="0">
+                <a:ln>
+                  <a:noFill/>
+                </a:ln>
+                <a:solidFill>
+                  <a:prstClr val="black"/>
+                </a:solidFill>
+                <a:effectLst/>
+                <a:uLnTx/>
+                <a:uFillTx/>
+                <a:latin typeface="Arial" panose="020B0604020202020204" pitchFamily="34" charset="0"/>
+                <a:ea typeface="ＭＳ Ｐゴシック" panose="020B0600070205080204" pitchFamily="34" charset="-128"/>
+              </a:endParaRPr>
+            </a:p>
+          </p:txBody>
+        </p:sp>
+      </p:grpSp>
+      <p:sp>
+        <p:nvSpPr>
+          <p:cNvPr id="30" name="AutoShape 50">
+            <a:extLst>
+              <a:ext uri="{FF2B5EF4-FFF2-40B4-BE49-F238E27FC236}">
+                <a16:creationId xmlns:a16="http://schemas.microsoft.com/office/drawing/2014/main" id="{92CECE13-0C4E-1B9D-9625-097B704B1D17}"/>
+              </a:ext>
+            </a:extLst>
+          </p:cNvPr>
+          <p:cNvSpPr>
+            <a:spLocks noChangeArrowheads="1"/>
+          </p:cNvSpPr>
+          <p:nvPr/>
+        </p:nvSpPr>
+        <p:spPr bwMode="auto">
+          <a:xfrm>
+            <a:off x="10458370" y="1763890"/>
+            <a:ext cx="168275" cy="252412"/>
+          </a:xfrm>
+          <a:prstGeom prst="diamond">
+            <a:avLst/>
+          </a:prstGeom>
+          <a:solidFill>
+            <a:sysClr val="windowText" lastClr="000000"/>
+          </a:solidFill>
+          <a:ln w="9525">
+            <a:solidFill>
+              <a:sysClr val="windowText" lastClr="000000"/>
+            </a:solidFill>
+            <a:miter lim="800000"/>
+            <a:headEnd/>
+            <a:tailEnd/>
+          </a:ln>
+        </p:spPr>
+        <p:txBody>
+          <a:bodyPr anchor="ctr">
+            <a:spAutoFit/>
+          </a:bodyPr>
+          <a:lstStyle/>
+          <a:p>
+            <a:pPr marL="0" marR="0" lvl="0" indent="0" defTabSz="914400" eaLnBrk="0" fontAlgn="auto" latinLnBrk="0" hangingPunct="0">
+              <a:lnSpc>
+                <a:spcPct val="100000"/>
+              </a:lnSpc>
+              <a:spcBef>
+                <a:spcPts val="0"/>
+              </a:spcBef>
+              <a:spcAft>
+                <a:spcPts val="0"/>
+              </a:spcAft>
+              <a:buClrTx/>
+              <a:buSzTx/>
+              <a:buFontTx/>
+              <a:buNone/>
+              <a:tabLst/>
+              <a:defRPr/>
+            </a:pPr>
+            <a:endParaRPr kumimoji="0" lang="en-US" sz="1800" b="0" i="0" u="none" strike="noStrike" kern="0" cap="none" spc="0" normalizeH="0" baseline="0" noProof="0" dirty="0">
+              <a:ln>
+                <a:noFill/>
+              </a:ln>
+              <a:solidFill>
+                <a:prstClr val="black"/>
+              </a:solidFill>
+              <a:effectLst/>
+              <a:uLnTx/>
+              <a:uFillTx/>
+              <a:latin typeface="Arial" panose="020B0604020202020204" pitchFamily="34" charset="0"/>
+              <a:ea typeface="ＭＳ Ｐゴシック" panose="020B0600070205080204" pitchFamily="34" charset="-128"/>
+            </a:endParaRPr>
+          </a:p>
+        </p:txBody>
+      </p:sp>
+      <p:sp>
+        <p:nvSpPr>
+          <p:cNvPr id="32" name="Rectangle 83">
+            <a:extLst>
+              <a:ext uri="{FF2B5EF4-FFF2-40B4-BE49-F238E27FC236}">
+                <a16:creationId xmlns:a16="http://schemas.microsoft.com/office/drawing/2014/main" id="{CC7A4D76-29C4-3F70-0D77-D2371DF7BBBE}"/>
+              </a:ext>
+            </a:extLst>
+          </p:cNvPr>
+          <p:cNvSpPr>
+            <a:spLocks noChangeArrowheads="1"/>
+          </p:cNvSpPr>
+          <p:nvPr/>
+        </p:nvSpPr>
+        <p:spPr bwMode="auto">
+          <a:xfrm>
+            <a:off x="7448367" y="1774086"/>
+            <a:ext cx="271084" cy="219291"/>
+          </a:xfrm>
+          <a:prstGeom prst="rect">
+            <a:avLst/>
+          </a:prstGeom>
+          <a:noFill/>
+          <a:ln w="9525">
+            <a:solidFill>
+              <a:sysClr val="windowText" lastClr="000000"/>
+            </a:solidFill>
+            <a:miter lim="800000"/>
+            <a:headEnd/>
+            <a:tailEnd/>
+          </a:ln>
+        </p:spPr>
+        <p:txBody>
+          <a:bodyPr wrap="none" anchor="ctr"/>
+          <a:lstStyle/>
+          <a:p>
+            <a:pPr algn="ctr" fontAlgn="auto">
+              <a:spcBef>
+                <a:spcPts val="0"/>
+              </a:spcBef>
+              <a:spcAft>
+                <a:spcPts val="0"/>
+              </a:spcAft>
+              <a:defRPr/>
+            </a:pPr>
+            <a:r>
+              <a:rPr lang="en-US" sz="1200" dirty="0">
+                <a:solidFill>
+                  <a:srgbClr val="000000"/>
+                </a:solidFill>
+              </a:rPr>
+              <a:t>“c”</a:t>
+            </a:r>
+            <a:endParaRPr lang="en-US" sz="1800" dirty="0"/>
+          </a:p>
+        </p:txBody>
+      </p:sp>
+      <p:cxnSp>
+        <p:nvCxnSpPr>
+          <p:cNvPr id="34" name="Verbinder: gewinkelt 87">
+            <a:extLst>
+              <a:ext uri="{FF2B5EF4-FFF2-40B4-BE49-F238E27FC236}">
+                <a16:creationId xmlns:a16="http://schemas.microsoft.com/office/drawing/2014/main" id="{8940144E-FC2E-C70C-6ADA-2B2CAEFE99CC}"/>
+              </a:ext>
+            </a:extLst>
+          </p:cNvPr>
+          <p:cNvCxnSpPr>
+            <a:cxnSpLocks/>
+            <a:stCxn id="30" idx="2"/>
+            <a:endCxn id="60" idx="0"/>
+          </p:cNvCxnSpPr>
+          <p:nvPr/>
+        </p:nvCxnSpPr>
+        <p:spPr>
+          <a:xfrm rot="5400000">
+            <a:off x="10274991" y="2283819"/>
+            <a:ext cx="535035" cy="1"/>
+          </a:xfrm>
+          <a:prstGeom prst="bentConnector3">
+            <a:avLst>
+              <a:gd name="adj1" fmla="val 50000"/>
+            </a:avLst>
+          </a:prstGeom>
+          <a:noFill/>
+          <a:ln w="9525">
+            <a:solidFill>
+              <a:sysClr val="windowText" lastClr="000000"/>
+            </a:solidFill>
+            <a:round/>
+            <a:headEnd/>
+            <a:tailEnd type="triangle" w="med" len="med"/>
+          </a:ln>
+        </p:spPr>
+      </p:cxnSp>
+      <p:sp>
+        <p:nvSpPr>
+          <p:cNvPr id="39" name="Rectangle 83">
+            <a:extLst>
+              <a:ext uri="{FF2B5EF4-FFF2-40B4-BE49-F238E27FC236}">
+                <a16:creationId xmlns:a16="http://schemas.microsoft.com/office/drawing/2014/main" id="{4EC6817E-D235-32EA-E287-826CBCD5C497}"/>
+              </a:ext>
+            </a:extLst>
+          </p:cNvPr>
+          <p:cNvSpPr>
+            <a:spLocks noChangeArrowheads="1"/>
+          </p:cNvSpPr>
+          <p:nvPr/>
+        </p:nvSpPr>
+        <p:spPr bwMode="auto">
+          <a:xfrm>
+            <a:off x="7820287" y="1768009"/>
+            <a:ext cx="271084" cy="219291"/>
+          </a:xfrm>
+          <a:prstGeom prst="rect">
+            <a:avLst/>
+          </a:prstGeom>
+          <a:noFill/>
+          <a:ln w="9525">
+            <a:solidFill>
+              <a:sysClr val="windowText" lastClr="000000"/>
+            </a:solidFill>
+            <a:miter lim="800000"/>
+            <a:headEnd/>
+            <a:tailEnd/>
+          </a:ln>
+        </p:spPr>
+        <p:txBody>
+          <a:bodyPr wrap="none" anchor="ctr"/>
+          <a:lstStyle/>
+          <a:p>
+            <a:pPr algn="ctr" fontAlgn="auto">
+              <a:spcBef>
+                <a:spcPts val="0"/>
+              </a:spcBef>
+              <a:spcAft>
+                <a:spcPts val="0"/>
+              </a:spcAft>
+              <a:defRPr/>
+            </a:pPr>
+            <a:r>
+              <a:rPr lang="en-US" sz="1200" dirty="0">
+                <a:solidFill>
+                  <a:srgbClr val="000000"/>
+                </a:solidFill>
+              </a:rPr>
+              <a:t>“b”</a:t>
+            </a:r>
+            <a:endParaRPr lang="en-US" sz="1800" dirty="0"/>
+          </a:p>
+        </p:txBody>
+      </p:sp>
+      <p:grpSp>
+        <p:nvGrpSpPr>
+          <p:cNvPr id="48" name="Gruppieren 31">
+            <a:extLst>
+              <a:ext uri="{FF2B5EF4-FFF2-40B4-BE49-F238E27FC236}">
+                <a16:creationId xmlns:a16="http://schemas.microsoft.com/office/drawing/2014/main" id="{E0CDA438-C03E-5276-EA27-8EBE9A2D3D8E}"/>
+              </a:ext>
+            </a:extLst>
+          </p:cNvPr>
+          <p:cNvGrpSpPr/>
+          <p:nvPr/>
+        </p:nvGrpSpPr>
+        <p:grpSpPr>
+          <a:xfrm>
+            <a:off x="9948899" y="2551337"/>
+            <a:ext cx="1187216" cy="412750"/>
+            <a:chOff x="4353342" y="1861556"/>
+            <a:chExt cx="3281668" cy="412750"/>
+          </a:xfrm>
+        </p:grpSpPr>
+        <p:sp>
+          <p:nvSpPr>
+            <p:cNvPr id="59" name="Text Box 82">
+              <a:extLst>
+                <a:ext uri="{FF2B5EF4-FFF2-40B4-BE49-F238E27FC236}">
+                  <a16:creationId xmlns:a16="http://schemas.microsoft.com/office/drawing/2014/main" id="{16C825D0-9ADB-A672-5916-EA745A966621}"/>
+                </a:ext>
+              </a:extLst>
+            </p:cNvPr>
+            <p:cNvSpPr txBox="1">
+              <a:spLocks noChangeArrowheads="1"/>
+            </p:cNvSpPr>
+            <p:nvPr/>
+          </p:nvSpPr>
+          <p:spPr bwMode="auto">
+            <a:xfrm>
+              <a:off x="5506303" y="1899656"/>
+              <a:ext cx="975747" cy="338554"/>
+            </a:xfrm>
+            <a:prstGeom prst="rect">
+              <a:avLst/>
+            </a:prstGeom>
+            <a:noFill/>
+            <a:ln w="9525">
+              <a:noFill/>
+              <a:miter lim="800000"/>
+              <a:headEnd/>
+              <a:tailEnd/>
+            </a:ln>
+          </p:spPr>
+          <p:txBody>
+            <a:bodyPr wrap="none">
+              <a:spAutoFit/>
+            </a:bodyPr>
+            <a:lstStyle/>
+            <a:p>
+              <a:pPr marL="0" marR="0" lvl="0" indent="0" algn="ctr" defTabSz="914400" eaLnBrk="0" fontAlgn="auto" latinLnBrk="0" hangingPunct="0">
+                <a:lnSpc>
+                  <a:spcPct val="100000"/>
+                </a:lnSpc>
+                <a:spcBef>
+                  <a:spcPts val="0"/>
+                </a:spcBef>
+                <a:spcAft>
+                  <a:spcPts val="0"/>
+                </a:spcAft>
+                <a:buClrTx/>
+                <a:buSzTx/>
+                <a:buFontTx/>
+                <a:buNone/>
+                <a:tabLst/>
+                <a:defRPr/>
+              </a:pPr>
+              <a:r>
+                <a:rPr lang="en-US" altLang="de-DE" sz="1600" u="sng" kern="0" dirty="0">
+                  <a:solidFill>
+                    <a:prstClr val="black"/>
+                  </a:solidFill>
+                </a:rPr>
+                <a:t>g</a:t>
+              </a:r>
+              <a:r>
+                <a:rPr kumimoji="0" lang="en-US" altLang="de-DE" sz="1600" b="0" i="0" u="sng" strike="noStrike" kern="0" cap="none" spc="0" normalizeH="0" baseline="0" noProof="0" dirty="0">
+                  <a:ln>
+                    <a:noFill/>
+                  </a:ln>
+                  <a:solidFill>
+                    <a:prstClr val="black"/>
+                  </a:solidFill>
+                  <a:effectLst/>
+                  <a:uLnTx/>
+                  <a:uFillTx/>
+                  <a:latin typeface="Arial" panose="020B0604020202020204" pitchFamily="34" charset="0"/>
+                  <a:ea typeface="ＭＳ Ｐゴシック" panose="020B0600070205080204" pitchFamily="34" charset="-128"/>
+                </a:rPr>
+                <a:t>:Function</a:t>
+              </a:r>
+            </a:p>
+          </p:txBody>
+        </p:sp>
+        <p:sp>
+          <p:nvSpPr>
+            <p:cNvPr id="60" name="Rectangle 83">
+              <a:extLst>
+                <a:ext uri="{FF2B5EF4-FFF2-40B4-BE49-F238E27FC236}">
+                  <a16:creationId xmlns:a16="http://schemas.microsoft.com/office/drawing/2014/main" id="{1F00CB09-920A-2A97-8676-F869619A0829}"/>
+                </a:ext>
+              </a:extLst>
+            </p:cNvPr>
+            <p:cNvSpPr>
+              <a:spLocks noChangeArrowheads="1"/>
+            </p:cNvSpPr>
+            <p:nvPr/>
+          </p:nvSpPr>
+          <p:spPr bwMode="auto">
+            <a:xfrm>
+              <a:off x="4353342" y="1861556"/>
+              <a:ext cx="3281668" cy="412750"/>
+            </a:xfrm>
+            <a:prstGeom prst="rect">
+              <a:avLst/>
+            </a:prstGeom>
+            <a:noFill/>
+            <a:ln w="9525">
+              <a:solidFill>
+                <a:sysClr val="windowText" lastClr="000000"/>
+              </a:solidFill>
+              <a:miter lim="800000"/>
+              <a:headEnd/>
+              <a:tailEnd/>
+            </a:ln>
+          </p:spPr>
+          <p:txBody>
+            <a:bodyPr wrap="none" anchor="ctr"/>
+            <a:lstStyle/>
+            <a:p>
+              <a:pPr marL="0" marR="0" lvl="0" indent="0" defTabSz="914400" eaLnBrk="0" fontAlgn="auto" latinLnBrk="0" hangingPunct="0">
+                <a:lnSpc>
+                  <a:spcPct val="100000"/>
+                </a:lnSpc>
+                <a:spcBef>
+                  <a:spcPts val="0"/>
+                </a:spcBef>
+                <a:spcAft>
+                  <a:spcPts val="0"/>
+                </a:spcAft>
+                <a:buClrTx/>
+                <a:buSzTx/>
+                <a:buFontTx/>
+                <a:buNone/>
+                <a:tabLst/>
+                <a:defRPr/>
+              </a:pPr>
+              <a:endParaRPr kumimoji="0" lang="en-US" sz="1800" b="0" i="0" u="none" strike="noStrike" kern="0" cap="none" spc="0" normalizeH="0" baseline="0" noProof="0" dirty="0">
+                <a:ln>
+                  <a:noFill/>
+                </a:ln>
+                <a:solidFill>
+                  <a:prstClr val="black"/>
+                </a:solidFill>
+                <a:effectLst/>
+                <a:uLnTx/>
+                <a:uFillTx/>
+                <a:latin typeface="Arial" panose="020B0604020202020204" pitchFamily="34" charset="0"/>
+                <a:ea typeface="ＭＳ Ｐゴシック" panose="020B0600070205080204" pitchFamily="34" charset="-128"/>
+              </a:endParaRPr>
+            </a:p>
+          </p:txBody>
+        </p:sp>
+      </p:grpSp>
+      <p:grpSp>
+        <p:nvGrpSpPr>
+          <p:cNvPr id="61" name="Gruppieren 31">
+            <a:extLst>
+              <a:ext uri="{FF2B5EF4-FFF2-40B4-BE49-F238E27FC236}">
+                <a16:creationId xmlns:a16="http://schemas.microsoft.com/office/drawing/2014/main" id="{FE64EC15-00D1-4DFB-939E-6148E4453747}"/>
+              </a:ext>
+            </a:extLst>
+          </p:cNvPr>
+          <p:cNvGrpSpPr/>
+          <p:nvPr/>
+        </p:nvGrpSpPr>
+        <p:grpSpPr>
+          <a:xfrm>
+            <a:off x="10705540" y="3287656"/>
+            <a:ext cx="1187216" cy="412750"/>
+            <a:chOff x="4353342" y="1861556"/>
+            <a:chExt cx="3281668" cy="412750"/>
+          </a:xfrm>
+        </p:grpSpPr>
+        <p:sp>
+          <p:nvSpPr>
+            <p:cNvPr id="62" name="Text Box 82">
+              <a:extLst>
+                <a:ext uri="{FF2B5EF4-FFF2-40B4-BE49-F238E27FC236}">
+                  <a16:creationId xmlns:a16="http://schemas.microsoft.com/office/drawing/2014/main" id="{676278BD-1B08-F600-2BFA-C5B77B7C8526}"/>
+                </a:ext>
+              </a:extLst>
+            </p:cNvPr>
+            <p:cNvSpPr txBox="1">
+              <a:spLocks noChangeArrowheads="1"/>
+            </p:cNvSpPr>
+            <p:nvPr/>
+          </p:nvSpPr>
+          <p:spPr bwMode="auto">
+            <a:xfrm>
+              <a:off x="4416307" y="1899656"/>
+              <a:ext cx="3155741" cy="338554"/>
+            </a:xfrm>
+            <a:prstGeom prst="rect">
+              <a:avLst/>
+            </a:prstGeom>
+            <a:noFill/>
+            <a:ln w="9525">
+              <a:noFill/>
+              <a:miter lim="800000"/>
+              <a:headEnd/>
+              <a:tailEnd/>
+            </a:ln>
+          </p:spPr>
+          <p:txBody>
+            <a:bodyPr wrap="none">
+              <a:spAutoFit/>
+            </a:bodyPr>
+            <a:lstStyle/>
+            <a:p>
+              <a:pPr marL="0" marR="0" lvl="0" indent="0" algn="ctr" defTabSz="914400" eaLnBrk="0" fontAlgn="auto" latinLnBrk="0" hangingPunct="0">
+                <a:lnSpc>
+                  <a:spcPct val="100000"/>
+                </a:lnSpc>
+                <a:spcBef>
+                  <a:spcPts val="0"/>
+                </a:spcBef>
+                <a:spcAft>
+                  <a:spcPts val="0"/>
+                </a:spcAft>
+                <a:buClrTx/>
+                <a:buSzTx/>
+                <a:buFontTx/>
+                <a:buNone/>
+                <a:tabLst/>
+                <a:defRPr/>
+              </a:pPr>
+              <a:r>
+                <a:rPr kumimoji="0" lang="en-US" altLang="de-DE" sz="1600" b="0" i="0" u="sng" strike="noStrike" kern="0" cap="none" spc="0" normalizeH="0" baseline="0" noProof="0" dirty="0">
+                  <a:ln>
+                    <a:noFill/>
+                  </a:ln>
+                  <a:solidFill>
+                    <a:prstClr val="black"/>
+                  </a:solidFill>
+                  <a:effectLst/>
+                  <a:uLnTx/>
+                  <a:uFillTx/>
+                  <a:latin typeface="Arial" panose="020B0604020202020204" pitchFamily="34" charset="0"/>
+                  <a:ea typeface="ＭＳ Ｐゴシック" panose="020B0600070205080204" pitchFamily="34" charset="-128"/>
+                </a:rPr>
+                <a:t>h:Function</a:t>
+              </a:r>
+            </a:p>
+          </p:txBody>
+        </p:sp>
+        <p:sp>
+          <p:nvSpPr>
+            <p:cNvPr id="63" name="Rectangle 83">
+              <a:extLst>
+                <a:ext uri="{FF2B5EF4-FFF2-40B4-BE49-F238E27FC236}">
+                  <a16:creationId xmlns:a16="http://schemas.microsoft.com/office/drawing/2014/main" id="{8B21E113-F84B-B890-0360-E3C83C2E3A73}"/>
+                </a:ext>
+              </a:extLst>
+            </p:cNvPr>
+            <p:cNvSpPr>
+              <a:spLocks noChangeArrowheads="1"/>
+            </p:cNvSpPr>
+            <p:nvPr/>
+          </p:nvSpPr>
+          <p:spPr bwMode="auto">
+            <a:xfrm>
+              <a:off x="4353342" y="1861556"/>
+              <a:ext cx="3281668" cy="412750"/>
+            </a:xfrm>
+            <a:prstGeom prst="rect">
+              <a:avLst/>
+            </a:prstGeom>
+            <a:noFill/>
+            <a:ln w="9525">
+              <a:solidFill>
+                <a:sysClr val="windowText" lastClr="000000"/>
+              </a:solidFill>
+              <a:miter lim="800000"/>
+              <a:headEnd/>
+              <a:tailEnd/>
+            </a:ln>
+          </p:spPr>
+          <p:txBody>
+            <a:bodyPr wrap="none" anchor="ctr"/>
+            <a:lstStyle/>
+            <a:p>
+              <a:pPr marL="0" marR="0" lvl="0" indent="0" defTabSz="914400" eaLnBrk="0" fontAlgn="auto" latinLnBrk="0" hangingPunct="0">
+                <a:lnSpc>
+                  <a:spcPct val="100000"/>
+                </a:lnSpc>
+                <a:spcBef>
+                  <a:spcPts val="0"/>
+                </a:spcBef>
+                <a:spcAft>
+                  <a:spcPts val="0"/>
+                </a:spcAft>
+                <a:buClrTx/>
+                <a:buSzTx/>
+                <a:buFontTx/>
+                <a:buNone/>
+                <a:tabLst/>
+                <a:defRPr/>
+              </a:pPr>
+              <a:endParaRPr kumimoji="0" lang="en-US" sz="1800" b="0" i="0" u="none" strike="noStrike" kern="0" cap="none" spc="0" normalizeH="0" baseline="0" noProof="0" dirty="0">
+                <a:ln>
+                  <a:noFill/>
+                </a:ln>
+                <a:solidFill>
+                  <a:prstClr val="black"/>
+                </a:solidFill>
+                <a:effectLst/>
+                <a:uLnTx/>
+                <a:uFillTx/>
+                <a:latin typeface="Arial" panose="020B0604020202020204" pitchFamily="34" charset="0"/>
+                <a:ea typeface="ＭＳ Ｐゴシック" panose="020B0600070205080204" pitchFamily="34" charset="-128"/>
+              </a:endParaRPr>
+            </a:p>
+          </p:txBody>
+        </p:sp>
+      </p:grpSp>
+      <p:cxnSp>
+        <p:nvCxnSpPr>
+          <p:cNvPr id="65" name="Verbinder: gewinkelt 87">
+            <a:extLst>
+              <a:ext uri="{FF2B5EF4-FFF2-40B4-BE49-F238E27FC236}">
+                <a16:creationId xmlns:a16="http://schemas.microsoft.com/office/drawing/2014/main" id="{A3074565-9991-4B2D-D102-1FEB4ECD3B25}"/>
+              </a:ext>
+            </a:extLst>
+          </p:cNvPr>
+          <p:cNvCxnSpPr>
+            <a:cxnSpLocks/>
+            <a:stCxn id="30" idx="2"/>
+            <a:endCxn id="63" idx="0"/>
+          </p:cNvCxnSpPr>
+          <p:nvPr/>
+        </p:nvCxnSpPr>
+        <p:spPr>
+          <a:xfrm rot="16200000" flipH="1">
+            <a:off x="10285151" y="2273659"/>
+            <a:ext cx="1271354" cy="756640"/>
+          </a:xfrm>
+          <a:prstGeom prst="bentConnector3">
+            <a:avLst>
+              <a:gd name="adj1" fmla="val 17857"/>
+            </a:avLst>
+          </a:prstGeom>
+          <a:noFill/>
+          <a:ln w="9525">
+            <a:solidFill>
+              <a:sysClr val="windowText" lastClr="000000"/>
+            </a:solidFill>
+            <a:round/>
+            <a:headEnd/>
+            <a:tailEnd type="triangle" w="med" len="med"/>
+          </a:ln>
+        </p:spPr>
+      </p:cxnSp>
+      <p:sp>
+        <p:nvSpPr>
+          <p:cNvPr id="107" name="Rectangle 83">
+            <a:extLst>
+              <a:ext uri="{FF2B5EF4-FFF2-40B4-BE49-F238E27FC236}">
+                <a16:creationId xmlns:a16="http://schemas.microsoft.com/office/drawing/2014/main" id="{0A9F6503-8D02-4F9D-06BF-48D408F18897}"/>
+              </a:ext>
+            </a:extLst>
+          </p:cNvPr>
+          <p:cNvSpPr>
+            <a:spLocks noChangeArrowheads="1"/>
+          </p:cNvSpPr>
+          <p:nvPr/>
+        </p:nvSpPr>
+        <p:spPr bwMode="auto">
+          <a:xfrm>
+            <a:off x="8809733" y="1767858"/>
+            <a:ext cx="271084" cy="219291"/>
+          </a:xfrm>
+          <a:prstGeom prst="rect">
+            <a:avLst/>
+          </a:prstGeom>
+          <a:noFill/>
+          <a:ln w="9525">
+            <a:solidFill>
+              <a:sysClr val="windowText" lastClr="000000"/>
+            </a:solidFill>
+            <a:miter lim="800000"/>
+            <a:headEnd/>
+            <a:tailEnd/>
+          </a:ln>
+        </p:spPr>
+        <p:txBody>
+          <a:bodyPr wrap="none" anchor="ctr"/>
+          <a:lstStyle/>
+          <a:p>
+            <a:pPr algn="ctr" fontAlgn="auto">
+              <a:spcBef>
+                <a:spcPts val="0"/>
+              </a:spcBef>
+              <a:spcAft>
+                <a:spcPts val="0"/>
+              </a:spcAft>
+              <a:defRPr/>
+            </a:pPr>
+            <a:r>
+              <a:rPr lang="en-US" sz="1200" dirty="0">
+                <a:solidFill>
+                  <a:srgbClr val="000000"/>
+                </a:solidFill>
+              </a:rPr>
+              <a:t>“a”</a:t>
+            </a:r>
+            <a:endParaRPr lang="en-US" sz="1800" dirty="0"/>
+          </a:p>
+        </p:txBody>
+      </p:sp>
+      <p:grpSp>
+        <p:nvGrpSpPr>
+          <p:cNvPr id="108" name="Gruppieren 31">
+            <a:extLst>
+              <a:ext uri="{FF2B5EF4-FFF2-40B4-BE49-F238E27FC236}">
+                <a16:creationId xmlns:a16="http://schemas.microsoft.com/office/drawing/2014/main" id="{64B41D1B-7775-9FF0-B2A3-40C568CD30E5}"/>
+              </a:ext>
+            </a:extLst>
+          </p:cNvPr>
+          <p:cNvGrpSpPr/>
+          <p:nvPr/>
+        </p:nvGrpSpPr>
+        <p:grpSpPr>
+          <a:xfrm>
+            <a:off x="8453424" y="3251560"/>
+            <a:ext cx="979137" cy="412750"/>
+            <a:chOff x="4353342" y="1861556"/>
+            <a:chExt cx="3281668" cy="412750"/>
+          </a:xfrm>
+        </p:grpSpPr>
+        <p:sp>
+          <p:nvSpPr>
+            <p:cNvPr id="109" name="Text Box 82">
+              <a:extLst>
+                <a:ext uri="{FF2B5EF4-FFF2-40B4-BE49-F238E27FC236}">
+                  <a16:creationId xmlns:a16="http://schemas.microsoft.com/office/drawing/2014/main" id="{55B42807-F944-800A-FF79-D164314B0017}"/>
+                </a:ext>
+              </a:extLst>
+            </p:cNvPr>
+            <p:cNvSpPr txBox="1">
+              <a:spLocks noChangeArrowheads="1"/>
+            </p:cNvSpPr>
+            <p:nvPr/>
+          </p:nvSpPr>
+          <p:spPr bwMode="auto">
+            <a:xfrm>
+              <a:off x="4606841" y="1899656"/>
+              <a:ext cx="2774678" cy="338554"/>
+            </a:xfrm>
+            <a:prstGeom prst="rect">
+              <a:avLst/>
+            </a:prstGeom>
+            <a:noFill/>
+            <a:ln w="9525">
+              <a:noFill/>
+              <a:miter lim="800000"/>
+              <a:headEnd/>
+              <a:tailEnd/>
+            </a:ln>
+          </p:spPr>
+          <p:txBody>
+            <a:bodyPr wrap="none">
+              <a:spAutoFit/>
+            </a:bodyPr>
+            <a:lstStyle/>
+            <a:p>
+              <a:pPr marL="0" marR="0" lvl="0" indent="0" algn="ctr" defTabSz="914400" eaLnBrk="0" fontAlgn="auto" latinLnBrk="0" hangingPunct="0">
+                <a:lnSpc>
+                  <a:spcPct val="100000"/>
+                </a:lnSpc>
+                <a:spcBef>
+                  <a:spcPts val="0"/>
+                </a:spcBef>
+                <a:spcAft>
+                  <a:spcPts val="0"/>
+                </a:spcAft>
+                <a:buClrTx/>
+                <a:buSzTx/>
+                <a:buFontTx/>
+                <a:buNone/>
+                <a:tabLst/>
+                <a:defRPr/>
+              </a:pPr>
+              <a:r>
+                <a:rPr kumimoji="0" lang="en-US" altLang="de-DE" sz="1600" b="0" i="0" u="sng" strike="noStrike" kern="0" cap="none" spc="0" normalizeH="0" baseline="0" noProof="0" dirty="0">
+                  <a:ln>
+                    <a:noFill/>
+                  </a:ln>
+                  <a:solidFill>
+                    <a:prstClr val="black"/>
+                  </a:solidFill>
+                  <a:effectLst/>
+                  <a:uLnTx/>
+                  <a:uFillTx/>
+                  <a:latin typeface="Arial" panose="020B0604020202020204" pitchFamily="34" charset="0"/>
+                  <a:ea typeface="ＭＳ Ｐゴシック" panose="020B0600070205080204" pitchFamily="34" charset="-128"/>
+                </a:rPr>
+                <a:t>:Channel</a:t>
+              </a:r>
+            </a:p>
+          </p:txBody>
+        </p:sp>
+        <p:sp>
+          <p:nvSpPr>
+            <p:cNvPr id="110" name="Rectangle 83">
+              <a:extLst>
+                <a:ext uri="{FF2B5EF4-FFF2-40B4-BE49-F238E27FC236}">
+                  <a16:creationId xmlns:a16="http://schemas.microsoft.com/office/drawing/2014/main" id="{BDADE4A1-C18E-FAF1-99BE-DAFBA868D5E0}"/>
+                </a:ext>
+              </a:extLst>
+            </p:cNvPr>
+            <p:cNvSpPr>
+              <a:spLocks noChangeArrowheads="1"/>
+            </p:cNvSpPr>
+            <p:nvPr/>
+          </p:nvSpPr>
+          <p:spPr bwMode="auto">
+            <a:xfrm>
+              <a:off x="4353342" y="1861556"/>
+              <a:ext cx="3281668" cy="412750"/>
+            </a:xfrm>
+            <a:prstGeom prst="rect">
+              <a:avLst/>
+            </a:prstGeom>
+            <a:noFill/>
+            <a:ln w="9525">
+              <a:solidFill>
+                <a:sysClr val="windowText" lastClr="000000"/>
+              </a:solidFill>
+              <a:miter lim="800000"/>
+              <a:headEnd/>
+              <a:tailEnd/>
+            </a:ln>
+          </p:spPr>
+          <p:txBody>
+            <a:bodyPr wrap="none" anchor="ctr"/>
+            <a:lstStyle/>
+            <a:p>
+              <a:pPr marL="0" marR="0" lvl="0" indent="0" defTabSz="914400" eaLnBrk="0" fontAlgn="auto" latinLnBrk="0" hangingPunct="0">
+                <a:lnSpc>
+                  <a:spcPct val="100000"/>
+                </a:lnSpc>
+                <a:spcBef>
+                  <a:spcPts val="0"/>
+                </a:spcBef>
+                <a:spcAft>
+                  <a:spcPts val="0"/>
+                </a:spcAft>
+                <a:buClrTx/>
+                <a:buSzTx/>
+                <a:buFontTx/>
+                <a:buNone/>
+                <a:tabLst/>
+                <a:defRPr/>
+              </a:pPr>
+              <a:endParaRPr kumimoji="0" lang="en-US" sz="1800" b="0" i="0" u="none" strike="noStrike" kern="0" cap="none" spc="0" normalizeH="0" baseline="0" noProof="0" dirty="0">
+                <a:ln>
+                  <a:noFill/>
+                </a:ln>
+                <a:solidFill>
+                  <a:prstClr val="black"/>
+                </a:solidFill>
+                <a:effectLst/>
+                <a:uLnTx/>
+                <a:uFillTx/>
+                <a:latin typeface="Arial" panose="020B0604020202020204" pitchFamily="34" charset="0"/>
+                <a:ea typeface="ＭＳ Ｐゴシック" panose="020B0600070205080204" pitchFamily="34" charset="-128"/>
+              </a:endParaRPr>
+            </a:p>
+          </p:txBody>
+        </p:sp>
+      </p:grpSp>
+      <p:grpSp>
+        <p:nvGrpSpPr>
+          <p:cNvPr id="115" name="Gruppieren 31">
+            <a:extLst>
+              <a:ext uri="{FF2B5EF4-FFF2-40B4-BE49-F238E27FC236}">
+                <a16:creationId xmlns:a16="http://schemas.microsoft.com/office/drawing/2014/main" id="{7E8AC5A1-D80C-5F7D-7C5D-B47E900AA16A}"/>
+              </a:ext>
+            </a:extLst>
+          </p:cNvPr>
+          <p:cNvGrpSpPr/>
+          <p:nvPr/>
+        </p:nvGrpSpPr>
+        <p:grpSpPr>
+          <a:xfrm>
+            <a:off x="8456435" y="2540410"/>
+            <a:ext cx="979137" cy="412750"/>
+            <a:chOff x="4353342" y="1861556"/>
+            <a:chExt cx="3281668" cy="412750"/>
+          </a:xfrm>
+        </p:grpSpPr>
+        <p:sp>
+          <p:nvSpPr>
+            <p:cNvPr id="116" name="Text Box 82">
+              <a:extLst>
+                <a:ext uri="{FF2B5EF4-FFF2-40B4-BE49-F238E27FC236}">
+                  <a16:creationId xmlns:a16="http://schemas.microsoft.com/office/drawing/2014/main" id="{BD16AA6D-DC92-8F81-63B5-EC8C41243EDD}"/>
+                </a:ext>
+              </a:extLst>
+            </p:cNvPr>
+            <p:cNvSpPr txBox="1">
+              <a:spLocks noChangeArrowheads="1"/>
+            </p:cNvSpPr>
+            <p:nvPr/>
+          </p:nvSpPr>
+          <p:spPr bwMode="auto">
+            <a:xfrm>
+              <a:off x="4606841" y="1899656"/>
+              <a:ext cx="2774678" cy="338554"/>
+            </a:xfrm>
+            <a:prstGeom prst="rect">
+              <a:avLst/>
+            </a:prstGeom>
+            <a:noFill/>
+            <a:ln w="9525">
+              <a:noFill/>
+              <a:miter lim="800000"/>
+              <a:headEnd/>
+              <a:tailEnd/>
+            </a:ln>
+          </p:spPr>
+          <p:txBody>
+            <a:bodyPr wrap="none">
+              <a:spAutoFit/>
+            </a:bodyPr>
+            <a:lstStyle/>
+            <a:p>
+              <a:pPr marL="0" marR="0" lvl="0" indent="0" algn="ctr" defTabSz="914400" eaLnBrk="0" fontAlgn="auto" latinLnBrk="0" hangingPunct="0">
+                <a:lnSpc>
+                  <a:spcPct val="100000"/>
+                </a:lnSpc>
+                <a:spcBef>
+                  <a:spcPts val="0"/>
+                </a:spcBef>
+                <a:spcAft>
+                  <a:spcPts val="0"/>
+                </a:spcAft>
+                <a:buClrTx/>
+                <a:buSzTx/>
+                <a:buFontTx/>
+                <a:buNone/>
+                <a:tabLst/>
+                <a:defRPr/>
+              </a:pPr>
+              <a:r>
+                <a:rPr kumimoji="0" lang="en-US" altLang="de-DE" sz="1600" b="0" i="0" u="sng" strike="noStrike" kern="0" cap="none" spc="0" normalizeH="0" baseline="0" noProof="0" dirty="0">
+                  <a:ln>
+                    <a:noFill/>
+                  </a:ln>
+                  <a:solidFill>
+                    <a:prstClr val="black"/>
+                  </a:solidFill>
+                  <a:effectLst/>
+                  <a:uLnTx/>
+                  <a:uFillTx/>
+                  <a:latin typeface="Arial" panose="020B0604020202020204" pitchFamily="34" charset="0"/>
+                  <a:ea typeface="ＭＳ Ｐゴシック" panose="020B0600070205080204" pitchFamily="34" charset="-128"/>
+                </a:rPr>
+                <a:t>:Channel</a:t>
+              </a:r>
+            </a:p>
+          </p:txBody>
+        </p:sp>
+        <p:sp>
+          <p:nvSpPr>
+            <p:cNvPr id="117" name="Rectangle 83">
+              <a:extLst>
+                <a:ext uri="{FF2B5EF4-FFF2-40B4-BE49-F238E27FC236}">
+                  <a16:creationId xmlns:a16="http://schemas.microsoft.com/office/drawing/2014/main" id="{2AAB5ADA-DBD9-BA68-5937-2A06B093EE83}"/>
+                </a:ext>
+              </a:extLst>
+            </p:cNvPr>
+            <p:cNvSpPr>
+              <a:spLocks noChangeArrowheads="1"/>
+            </p:cNvSpPr>
+            <p:nvPr/>
+          </p:nvSpPr>
+          <p:spPr bwMode="auto">
+            <a:xfrm>
+              <a:off x="4353342" y="1861556"/>
+              <a:ext cx="3281668" cy="412750"/>
+            </a:xfrm>
+            <a:prstGeom prst="rect">
+              <a:avLst/>
+            </a:prstGeom>
+            <a:noFill/>
+            <a:ln w="9525">
+              <a:solidFill>
+                <a:sysClr val="windowText" lastClr="000000"/>
+              </a:solidFill>
+              <a:miter lim="800000"/>
+              <a:headEnd/>
+              <a:tailEnd/>
+            </a:ln>
+          </p:spPr>
+          <p:txBody>
+            <a:bodyPr wrap="none" anchor="ctr"/>
+            <a:lstStyle/>
+            <a:p>
+              <a:pPr marL="0" marR="0" lvl="0" indent="0" defTabSz="914400" eaLnBrk="0" fontAlgn="auto" latinLnBrk="0" hangingPunct="0">
+                <a:lnSpc>
+                  <a:spcPct val="100000"/>
+                </a:lnSpc>
+                <a:spcBef>
+                  <a:spcPts val="0"/>
+                </a:spcBef>
+                <a:spcAft>
+                  <a:spcPts val="0"/>
+                </a:spcAft>
+                <a:buClrTx/>
+                <a:buSzTx/>
+                <a:buFontTx/>
+                <a:buNone/>
+                <a:tabLst/>
+                <a:defRPr/>
+              </a:pPr>
+              <a:endParaRPr kumimoji="0" lang="en-US" sz="1800" b="0" i="0" u="none" strike="noStrike" kern="0" cap="none" spc="0" normalizeH="0" baseline="0" noProof="0" dirty="0">
+                <a:ln>
+                  <a:noFill/>
+                </a:ln>
+                <a:solidFill>
+                  <a:prstClr val="black"/>
+                </a:solidFill>
+                <a:effectLst/>
+                <a:uLnTx/>
+                <a:uFillTx/>
+                <a:latin typeface="Arial" panose="020B0604020202020204" pitchFamily="34" charset="0"/>
+                <a:ea typeface="ＭＳ Ｐゴシック" panose="020B0600070205080204" pitchFamily="34" charset="-128"/>
+              </a:endParaRPr>
+            </a:p>
+          </p:txBody>
+        </p:sp>
+      </p:grpSp>
+      <p:grpSp>
+        <p:nvGrpSpPr>
+          <p:cNvPr id="118" name="Gruppieren 31">
+            <a:extLst>
+              <a:ext uri="{FF2B5EF4-FFF2-40B4-BE49-F238E27FC236}">
+                <a16:creationId xmlns:a16="http://schemas.microsoft.com/office/drawing/2014/main" id="{8A950902-A1A8-5FEA-5D09-5476683E6337}"/>
+              </a:ext>
+            </a:extLst>
+          </p:cNvPr>
+          <p:cNvGrpSpPr/>
+          <p:nvPr/>
+        </p:nvGrpSpPr>
+        <p:grpSpPr>
+          <a:xfrm>
+            <a:off x="10215971" y="4208443"/>
+            <a:ext cx="979137" cy="412750"/>
+            <a:chOff x="4353342" y="1861556"/>
+            <a:chExt cx="3281668" cy="412750"/>
+          </a:xfrm>
+        </p:grpSpPr>
+        <p:sp>
+          <p:nvSpPr>
+            <p:cNvPr id="119" name="Text Box 82">
+              <a:extLst>
+                <a:ext uri="{FF2B5EF4-FFF2-40B4-BE49-F238E27FC236}">
+                  <a16:creationId xmlns:a16="http://schemas.microsoft.com/office/drawing/2014/main" id="{0076AD7F-470E-DE60-F470-B057F61034A6}"/>
+                </a:ext>
+              </a:extLst>
+            </p:cNvPr>
+            <p:cNvSpPr txBox="1">
+              <a:spLocks noChangeArrowheads="1"/>
+            </p:cNvSpPr>
+            <p:nvPr/>
+          </p:nvSpPr>
+          <p:spPr bwMode="auto">
+            <a:xfrm>
+              <a:off x="4606841" y="1899656"/>
+              <a:ext cx="2774678" cy="338554"/>
+            </a:xfrm>
+            <a:prstGeom prst="rect">
+              <a:avLst/>
+            </a:prstGeom>
+            <a:noFill/>
+            <a:ln w="9525">
+              <a:noFill/>
+              <a:miter lim="800000"/>
+              <a:headEnd/>
+              <a:tailEnd/>
+            </a:ln>
+          </p:spPr>
+          <p:txBody>
+            <a:bodyPr wrap="none">
+              <a:spAutoFit/>
+            </a:bodyPr>
+            <a:lstStyle/>
+            <a:p>
+              <a:pPr marL="0" marR="0" lvl="0" indent="0" algn="ctr" defTabSz="914400" eaLnBrk="0" fontAlgn="auto" latinLnBrk="0" hangingPunct="0">
+                <a:lnSpc>
+                  <a:spcPct val="100000"/>
+                </a:lnSpc>
+                <a:spcBef>
+                  <a:spcPts val="0"/>
+                </a:spcBef>
+                <a:spcAft>
+                  <a:spcPts val="0"/>
+                </a:spcAft>
+                <a:buClrTx/>
+                <a:buSzTx/>
+                <a:buFontTx/>
+                <a:buNone/>
+                <a:tabLst/>
+                <a:defRPr/>
+              </a:pPr>
+              <a:r>
+                <a:rPr kumimoji="0" lang="en-US" altLang="de-DE" sz="1600" b="0" i="0" u="sng" strike="noStrike" kern="0" cap="none" spc="0" normalizeH="0" baseline="0" noProof="0" dirty="0">
+                  <a:ln>
+                    <a:noFill/>
+                  </a:ln>
+                  <a:solidFill>
+                    <a:prstClr val="black"/>
+                  </a:solidFill>
+                  <a:effectLst/>
+                  <a:uLnTx/>
+                  <a:uFillTx/>
+                  <a:latin typeface="Arial" panose="020B0604020202020204" pitchFamily="34" charset="0"/>
+                  <a:ea typeface="ＭＳ Ｐゴシック" panose="020B0600070205080204" pitchFamily="34" charset="-128"/>
+                </a:rPr>
+                <a:t>:Channel</a:t>
+              </a:r>
+            </a:p>
+          </p:txBody>
+        </p:sp>
+        <p:sp>
+          <p:nvSpPr>
+            <p:cNvPr id="120" name="Rectangle 83">
+              <a:extLst>
+                <a:ext uri="{FF2B5EF4-FFF2-40B4-BE49-F238E27FC236}">
+                  <a16:creationId xmlns:a16="http://schemas.microsoft.com/office/drawing/2014/main" id="{285552F7-3421-B985-5CF6-8836C86D0A30}"/>
+                </a:ext>
+              </a:extLst>
+            </p:cNvPr>
+            <p:cNvSpPr>
+              <a:spLocks noChangeArrowheads="1"/>
+            </p:cNvSpPr>
+            <p:nvPr/>
+          </p:nvSpPr>
+          <p:spPr bwMode="auto">
+            <a:xfrm>
+              <a:off x="4353342" y="1861556"/>
+              <a:ext cx="3281668" cy="412750"/>
+            </a:xfrm>
+            <a:prstGeom prst="rect">
+              <a:avLst/>
+            </a:prstGeom>
+            <a:noFill/>
+            <a:ln w="9525">
+              <a:solidFill>
+                <a:sysClr val="windowText" lastClr="000000"/>
+              </a:solidFill>
+              <a:miter lim="800000"/>
+              <a:headEnd/>
+              <a:tailEnd/>
+            </a:ln>
+          </p:spPr>
+          <p:txBody>
+            <a:bodyPr wrap="none" anchor="ctr"/>
+            <a:lstStyle/>
+            <a:p>
+              <a:pPr marL="0" marR="0" lvl="0" indent="0" defTabSz="914400" eaLnBrk="0" fontAlgn="auto" latinLnBrk="0" hangingPunct="0">
+                <a:lnSpc>
+                  <a:spcPct val="100000"/>
+                </a:lnSpc>
+                <a:spcBef>
+                  <a:spcPts val="0"/>
+                </a:spcBef>
+                <a:spcAft>
+                  <a:spcPts val="0"/>
+                </a:spcAft>
+                <a:buClrTx/>
+                <a:buSzTx/>
+                <a:buFontTx/>
+                <a:buNone/>
+                <a:tabLst/>
+                <a:defRPr/>
+              </a:pPr>
+              <a:endParaRPr kumimoji="0" lang="en-US" sz="1800" b="0" i="0" u="none" strike="noStrike" kern="0" cap="none" spc="0" normalizeH="0" baseline="0" noProof="0" dirty="0">
+                <a:ln>
+                  <a:noFill/>
+                </a:ln>
+                <a:solidFill>
+                  <a:prstClr val="black"/>
+                </a:solidFill>
+                <a:effectLst/>
+                <a:uLnTx/>
+                <a:uFillTx/>
+                <a:latin typeface="Arial" panose="020B0604020202020204" pitchFamily="34" charset="0"/>
+                <a:ea typeface="ＭＳ Ｐゴシック" panose="020B0600070205080204" pitchFamily="34" charset="-128"/>
+              </a:endParaRPr>
+            </a:p>
+          </p:txBody>
+        </p:sp>
+      </p:grpSp>
+      <p:sp>
+        <p:nvSpPr>
+          <p:cNvPr id="128" name="Rectangle 83">
+            <a:extLst>
+              <a:ext uri="{FF2B5EF4-FFF2-40B4-BE49-F238E27FC236}">
+                <a16:creationId xmlns:a16="http://schemas.microsoft.com/office/drawing/2014/main" id="{4280F45F-BFCF-456E-3BC4-86A9E512A8FD}"/>
+              </a:ext>
+            </a:extLst>
+          </p:cNvPr>
+          <p:cNvSpPr>
+            <a:spLocks noChangeArrowheads="1"/>
+          </p:cNvSpPr>
+          <p:nvPr/>
+        </p:nvSpPr>
+        <p:spPr bwMode="auto">
+          <a:xfrm>
+            <a:off x="9677814" y="2637140"/>
+            <a:ext cx="271084" cy="219291"/>
+          </a:xfrm>
+          <a:prstGeom prst="rect">
+            <a:avLst/>
+          </a:prstGeom>
+          <a:noFill/>
+          <a:ln w="9525">
+            <a:solidFill>
+              <a:sysClr val="windowText" lastClr="000000"/>
+            </a:solidFill>
+            <a:miter lim="800000"/>
+            <a:headEnd/>
+            <a:tailEnd/>
+          </a:ln>
+        </p:spPr>
+        <p:txBody>
+          <a:bodyPr wrap="none" anchor="ctr"/>
+          <a:lstStyle/>
+          <a:p>
+            <a:pPr algn="ctr" fontAlgn="auto">
+              <a:spcBef>
+                <a:spcPts val="0"/>
+              </a:spcBef>
+              <a:spcAft>
+                <a:spcPts val="0"/>
+              </a:spcAft>
+              <a:defRPr/>
+            </a:pPr>
+            <a:r>
+              <a:rPr lang="en-US" sz="1200" dirty="0">
+                <a:solidFill>
+                  <a:srgbClr val="000000"/>
+                </a:solidFill>
+              </a:rPr>
+              <a:t>“b”</a:t>
+            </a:r>
+            <a:endParaRPr lang="en-US" sz="1800" dirty="0"/>
+          </a:p>
+        </p:txBody>
+      </p:sp>
+      <p:cxnSp>
+        <p:nvCxnSpPr>
+          <p:cNvPr id="129" name="Verbinder: gewinkelt 87">
+            <a:extLst>
+              <a:ext uri="{FF2B5EF4-FFF2-40B4-BE49-F238E27FC236}">
+                <a16:creationId xmlns:a16="http://schemas.microsoft.com/office/drawing/2014/main" id="{A1704D64-AF38-CED0-318A-90203AA027D8}"/>
+              </a:ext>
+            </a:extLst>
+          </p:cNvPr>
+          <p:cNvCxnSpPr>
+            <a:cxnSpLocks/>
+            <a:stCxn id="128" idx="1"/>
+            <a:endCxn id="117" idx="3"/>
+          </p:cNvCxnSpPr>
+          <p:nvPr/>
+        </p:nvCxnSpPr>
+        <p:spPr>
+          <a:xfrm rot="10800000">
+            <a:off x="9435572" y="2746786"/>
+            <a:ext cx="242242" cy="1"/>
+          </a:xfrm>
+          <a:prstGeom prst="bentConnector3">
+            <a:avLst>
+              <a:gd name="adj1" fmla="val 50000"/>
+            </a:avLst>
+          </a:prstGeom>
+          <a:noFill/>
+          <a:ln w="9525">
+            <a:solidFill>
+              <a:sysClr val="windowText" lastClr="000000"/>
+            </a:solidFill>
+            <a:round/>
+            <a:headEnd/>
+            <a:tailEnd type="triangle" w="med" len="med"/>
+          </a:ln>
+        </p:spPr>
+      </p:cxnSp>
+      <p:cxnSp>
+        <p:nvCxnSpPr>
+          <p:cNvPr id="134" name="Verbinder: gewinkelt 87">
+            <a:extLst>
+              <a:ext uri="{FF2B5EF4-FFF2-40B4-BE49-F238E27FC236}">
+                <a16:creationId xmlns:a16="http://schemas.microsoft.com/office/drawing/2014/main" id="{09071D55-B9D6-BF63-0FAA-2CFD89C83C78}"/>
+              </a:ext>
+            </a:extLst>
+          </p:cNvPr>
+          <p:cNvCxnSpPr>
+            <a:cxnSpLocks/>
+            <a:stCxn id="107" idx="2"/>
+            <a:endCxn id="117" idx="0"/>
+          </p:cNvCxnSpPr>
+          <p:nvPr/>
+        </p:nvCxnSpPr>
+        <p:spPr>
+          <a:xfrm rot="16200000" flipH="1">
+            <a:off x="8669009" y="2263414"/>
+            <a:ext cx="553261" cy="729"/>
+          </a:xfrm>
+          <a:prstGeom prst="bentConnector3">
+            <a:avLst>
+              <a:gd name="adj1" fmla="val 50000"/>
+            </a:avLst>
+          </a:prstGeom>
+          <a:noFill/>
+          <a:ln w="9525">
+            <a:solidFill>
+              <a:sysClr val="windowText" lastClr="000000"/>
+            </a:solidFill>
+            <a:round/>
+            <a:headEnd/>
+            <a:tailEnd type="triangle" w="med" len="med"/>
+          </a:ln>
+        </p:spPr>
+      </p:cxnSp>
+      <p:sp>
+        <p:nvSpPr>
+          <p:cNvPr id="139" name="Rectangle 83">
+            <a:extLst>
+              <a:ext uri="{FF2B5EF4-FFF2-40B4-BE49-F238E27FC236}">
+                <a16:creationId xmlns:a16="http://schemas.microsoft.com/office/drawing/2014/main" id="{05D93185-28C7-EE2D-BF70-81639AE6D505}"/>
+              </a:ext>
+            </a:extLst>
+          </p:cNvPr>
+          <p:cNvSpPr>
+            <a:spLocks noChangeArrowheads="1"/>
+          </p:cNvSpPr>
+          <p:nvPr/>
+        </p:nvSpPr>
+        <p:spPr bwMode="auto">
+          <a:xfrm>
+            <a:off x="10031135" y="2960458"/>
+            <a:ext cx="271084" cy="219291"/>
+          </a:xfrm>
+          <a:prstGeom prst="rect">
+            <a:avLst/>
+          </a:prstGeom>
+          <a:noFill/>
+          <a:ln w="9525">
+            <a:solidFill>
+              <a:sysClr val="windowText" lastClr="000000"/>
+            </a:solidFill>
+            <a:miter lim="800000"/>
+            <a:headEnd/>
+            <a:tailEnd/>
+          </a:ln>
+        </p:spPr>
+        <p:txBody>
+          <a:bodyPr wrap="none" anchor="ctr"/>
+          <a:lstStyle/>
+          <a:p>
+            <a:pPr algn="ctr" fontAlgn="auto">
+              <a:spcBef>
+                <a:spcPts val="0"/>
+              </a:spcBef>
+              <a:spcAft>
+                <a:spcPts val="0"/>
+              </a:spcAft>
+              <a:defRPr/>
+            </a:pPr>
+            <a:r>
+              <a:rPr lang="en-US" sz="1200" dirty="0">
+                <a:solidFill>
+                  <a:srgbClr val="000000"/>
+                </a:solidFill>
+              </a:rPr>
+              <a:t>“c”</a:t>
+            </a:r>
+            <a:endParaRPr lang="en-US" sz="1800" dirty="0"/>
+          </a:p>
+        </p:txBody>
+      </p:sp>
+      <p:cxnSp>
+        <p:nvCxnSpPr>
+          <p:cNvPr id="140" name="Verbinder: gewinkelt 87">
+            <a:extLst>
+              <a:ext uri="{FF2B5EF4-FFF2-40B4-BE49-F238E27FC236}">
+                <a16:creationId xmlns:a16="http://schemas.microsoft.com/office/drawing/2014/main" id="{20A7775D-F80A-BBBA-6B14-3FBF20E1ABB5}"/>
+              </a:ext>
+            </a:extLst>
+          </p:cNvPr>
+          <p:cNvCxnSpPr>
+            <a:cxnSpLocks/>
+            <a:stCxn id="139" idx="2"/>
+            <a:endCxn id="110" idx="3"/>
+          </p:cNvCxnSpPr>
+          <p:nvPr/>
+        </p:nvCxnSpPr>
+        <p:spPr>
+          <a:xfrm rot="5400000">
+            <a:off x="9660526" y="2951784"/>
+            <a:ext cx="278186" cy="734116"/>
+          </a:xfrm>
+          <a:prstGeom prst="bentConnector2">
+            <a:avLst/>
+          </a:prstGeom>
+          <a:noFill/>
+          <a:ln w="9525">
+            <a:solidFill>
+              <a:sysClr val="windowText" lastClr="000000"/>
+            </a:solidFill>
+            <a:round/>
+            <a:headEnd/>
+            <a:tailEnd type="triangle" w="med" len="med"/>
+          </a:ln>
+        </p:spPr>
+      </p:cxnSp>
+      <p:cxnSp>
+        <p:nvCxnSpPr>
+          <p:cNvPr id="143" name="Verbinder: gewinkelt 87">
+            <a:extLst>
+              <a:ext uri="{FF2B5EF4-FFF2-40B4-BE49-F238E27FC236}">
+                <a16:creationId xmlns:a16="http://schemas.microsoft.com/office/drawing/2014/main" id="{2F898ED7-F032-D331-6066-C05DD9DA5528}"/>
+              </a:ext>
+            </a:extLst>
+          </p:cNvPr>
+          <p:cNvCxnSpPr>
+            <a:cxnSpLocks/>
+            <a:stCxn id="39" idx="2"/>
+            <a:endCxn id="110" idx="1"/>
+          </p:cNvCxnSpPr>
+          <p:nvPr/>
+        </p:nvCxnSpPr>
+        <p:spPr>
+          <a:xfrm rot="16200000" flipH="1">
+            <a:off x="7469309" y="2473819"/>
+            <a:ext cx="1470635" cy="497595"/>
+          </a:xfrm>
+          <a:prstGeom prst="bentConnector2">
+            <a:avLst/>
+          </a:prstGeom>
+          <a:noFill/>
+          <a:ln w="9525">
+            <a:solidFill>
+              <a:sysClr val="windowText" lastClr="000000"/>
+            </a:solidFill>
+            <a:round/>
+            <a:headEnd/>
+            <a:tailEnd type="triangle" w="med" len="med"/>
+          </a:ln>
+        </p:spPr>
+      </p:cxnSp>
+      <p:sp>
+        <p:nvSpPr>
+          <p:cNvPr id="146" name="Rectangle 83">
+            <a:extLst>
+              <a:ext uri="{FF2B5EF4-FFF2-40B4-BE49-F238E27FC236}">
+                <a16:creationId xmlns:a16="http://schemas.microsoft.com/office/drawing/2014/main" id="{FF1D91B2-4B44-A792-79A9-9AFC8E422A6E}"/>
+              </a:ext>
+            </a:extLst>
+          </p:cNvPr>
+          <p:cNvSpPr>
+            <a:spLocks noChangeArrowheads="1"/>
+          </p:cNvSpPr>
+          <p:nvPr/>
+        </p:nvSpPr>
+        <p:spPr bwMode="auto">
+          <a:xfrm>
+            <a:off x="10367273" y="2970462"/>
+            <a:ext cx="271084" cy="219291"/>
+          </a:xfrm>
+          <a:prstGeom prst="rect">
+            <a:avLst/>
+          </a:prstGeom>
+          <a:noFill/>
+          <a:ln w="9525">
+            <a:solidFill>
+              <a:sysClr val="windowText" lastClr="000000"/>
+            </a:solidFill>
+            <a:miter lim="800000"/>
+            <a:headEnd/>
+            <a:tailEnd/>
+          </a:ln>
+        </p:spPr>
+        <p:txBody>
+          <a:bodyPr wrap="none" anchor="ctr"/>
+          <a:lstStyle/>
+          <a:p>
+            <a:pPr algn="ctr" fontAlgn="auto">
+              <a:spcBef>
+                <a:spcPts val="0"/>
+              </a:spcBef>
+              <a:spcAft>
+                <a:spcPts val="0"/>
+              </a:spcAft>
+              <a:defRPr/>
+            </a:pPr>
+            <a:r>
+              <a:rPr lang="en-US" sz="1200" dirty="0">
+                <a:solidFill>
+                  <a:srgbClr val="000000"/>
+                </a:solidFill>
+              </a:rPr>
+              <a:t>“d”</a:t>
+            </a:r>
+            <a:endParaRPr lang="en-US" sz="1800" dirty="0"/>
+          </a:p>
+        </p:txBody>
+      </p:sp>
+      <p:cxnSp>
+        <p:nvCxnSpPr>
+          <p:cNvPr id="147" name="Verbinder: gewinkelt 87">
+            <a:extLst>
+              <a:ext uri="{FF2B5EF4-FFF2-40B4-BE49-F238E27FC236}">
+                <a16:creationId xmlns:a16="http://schemas.microsoft.com/office/drawing/2014/main" id="{E45CC561-A282-1FC1-049A-1329C17F1E62}"/>
+              </a:ext>
+            </a:extLst>
+          </p:cNvPr>
+          <p:cNvCxnSpPr>
+            <a:cxnSpLocks/>
+            <a:stCxn id="146" idx="2"/>
+          </p:cNvCxnSpPr>
+          <p:nvPr/>
+        </p:nvCxnSpPr>
+        <p:spPr>
+          <a:xfrm rot="5400000">
+            <a:off x="9993469" y="3699099"/>
+            <a:ext cx="1018692" cy="12700"/>
+          </a:xfrm>
+          <a:prstGeom prst="bentConnector3">
+            <a:avLst>
+              <a:gd name="adj1" fmla="val 50000"/>
+            </a:avLst>
+          </a:prstGeom>
+          <a:noFill/>
+          <a:ln w="9525">
+            <a:solidFill>
+              <a:sysClr val="windowText" lastClr="000000"/>
+            </a:solidFill>
+            <a:round/>
+            <a:headEnd/>
+            <a:tailEnd type="triangle" w="med" len="med"/>
+          </a:ln>
+        </p:spPr>
+      </p:cxnSp>
+      <p:sp>
+        <p:nvSpPr>
+          <p:cNvPr id="150" name="Rectangle 83">
+            <a:extLst>
+              <a:ext uri="{FF2B5EF4-FFF2-40B4-BE49-F238E27FC236}">
+                <a16:creationId xmlns:a16="http://schemas.microsoft.com/office/drawing/2014/main" id="{622E0E5D-3B6E-44DF-8F16-EBE2C71BF09B}"/>
+              </a:ext>
+            </a:extLst>
+          </p:cNvPr>
+          <p:cNvSpPr>
+            <a:spLocks noChangeArrowheads="1"/>
+          </p:cNvSpPr>
+          <p:nvPr/>
+        </p:nvSpPr>
+        <p:spPr bwMode="auto">
+          <a:xfrm>
+            <a:off x="10728319" y="3710410"/>
+            <a:ext cx="271084" cy="219291"/>
+          </a:xfrm>
+          <a:prstGeom prst="rect">
+            <a:avLst/>
+          </a:prstGeom>
+          <a:noFill/>
+          <a:ln w="9525">
+            <a:solidFill>
+              <a:sysClr val="windowText" lastClr="000000"/>
+            </a:solidFill>
+            <a:miter lim="800000"/>
+            <a:headEnd/>
+            <a:tailEnd/>
+          </a:ln>
+        </p:spPr>
+        <p:txBody>
+          <a:bodyPr wrap="none" anchor="ctr"/>
+          <a:lstStyle/>
+          <a:p>
+            <a:pPr algn="ctr" fontAlgn="auto">
+              <a:spcBef>
+                <a:spcPts val="0"/>
+              </a:spcBef>
+              <a:spcAft>
+                <a:spcPts val="0"/>
+              </a:spcAft>
+              <a:defRPr/>
+            </a:pPr>
+            <a:r>
+              <a:rPr lang="en-US" sz="1200" dirty="0">
+                <a:solidFill>
+                  <a:srgbClr val="000000"/>
+                </a:solidFill>
+              </a:rPr>
+              <a:t>“e”</a:t>
+            </a:r>
+            <a:endParaRPr lang="en-US" sz="1800" dirty="0"/>
+          </a:p>
+        </p:txBody>
+      </p:sp>
+      <p:cxnSp>
+        <p:nvCxnSpPr>
+          <p:cNvPr id="151" name="Verbinder: gewinkelt 87">
+            <a:extLst>
+              <a:ext uri="{FF2B5EF4-FFF2-40B4-BE49-F238E27FC236}">
+                <a16:creationId xmlns:a16="http://schemas.microsoft.com/office/drawing/2014/main" id="{F2ADCBA9-2D64-517D-8963-56AF1DA3959D}"/>
+              </a:ext>
+            </a:extLst>
+          </p:cNvPr>
+          <p:cNvCxnSpPr>
+            <a:cxnSpLocks/>
+          </p:cNvCxnSpPr>
+          <p:nvPr/>
+        </p:nvCxnSpPr>
+        <p:spPr>
+          <a:xfrm rot="16200000" flipH="1">
+            <a:off x="10719820" y="4062786"/>
+            <a:ext cx="288080" cy="6"/>
+          </a:xfrm>
+          <a:prstGeom prst="bentConnector3">
+            <a:avLst>
+              <a:gd name="adj1" fmla="val 50000"/>
+            </a:avLst>
+          </a:prstGeom>
+          <a:noFill/>
+          <a:ln w="9525">
+            <a:solidFill>
+              <a:sysClr val="windowText" lastClr="000000"/>
+            </a:solidFill>
+            <a:round/>
+            <a:headEnd/>
+            <a:tailEnd type="triangle" w="med" len="med"/>
+          </a:ln>
+        </p:spPr>
+      </p:cxnSp>
+      <p:grpSp>
+        <p:nvGrpSpPr>
+          <p:cNvPr id="177" name="Gruppieren 31">
+            <a:extLst>
+              <a:ext uri="{FF2B5EF4-FFF2-40B4-BE49-F238E27FC236}">
+                <a16:creationId xmlns:a16="http://schemas.microsoft.com/office/drawing/2014/main" id="{6FBC0E50-28F7-DA48-DF36-C959F72A26B4}"/>
+              </a:ext>
+            </a:extLst>
+          </p:cNvPr>
+          <p:cNvGrpSpPr/>
+          <p:nvPr/>
+        </p:nvGrpSpPr>
+        <p:grpSpPr>
+          <a:xfrm>
+            <a:off x="10226390" y="4958395"/>
+            <a:ext cx="979137" cy="412750"/>
+            <a:chOff x="4353342" y="1861556"/>
+            <a:chExt cx="3281668" cy="412750"/>
+          </a:xfrm>
+        </p:grpSpPr>
+        <p:sp>
+          <p:nvSpPr>
+            <p:cNvPr id="178" name="Text Box 82">
+              <a:extLst>
+                <a:ext uri="{FF2B5EF4-FFF2-40B4-BE49-F238E27FC236}">
+                  <a16:creationId xmlns:a16="http://schemas.microsoft.com/office/drawing/2014/main" id="{C18D4368-71C3-6C92-3908-F7FD6FAC392C}"/>
+                </a:ext>
+              </a:extLst>
+            </p:cNvPr>
+            <p:cNvSpPr txBox="1">
+              <a:spLocks noChangeArrowheads="1"/>
+            </p:cNvSpPr>
+            <p:nvPr/>
+          </p:nvSpPr>
+          <p:spPr bwMode="auto">
+            <a:xfrm>
+              <a:off x="4606841" y="1899656"/>
+              <a:ext cx="2774678" cy="338554"/>
+            </a:xfrm>
+            <a:prstGeom prst="rect">
+              <a:avLst/>
+            </a:prstGeom>
+            <a:noFill/>
+            <a:ln w="9525">
+              <a:noFill/>
+              <a:miter lim="800000"/>
+              <a:headEnd/>
+              <a:tailEnd/>
+            </a:ln>
+          </p:spPr>
+          <p:txBody>
+            <a:bodyPr wrap="none">
+              <a:spAutoFit/>
+            </a:bodyPr>
+            <a:lstStyle/>
+            <a:p>
+              <a:pPr marL="0" marR="0" lvl="0" indent="0" algn="ctr" defTabSz="914400" eaLnBrk="0" fontAlgn="auto" latinLnBrk="0" hangingPunct="0">
+                <a:lnSpc>
+                  <a:spcPct val="100000"/>
+                </a:lnSpc>
+                <a:spcBef>
+                  <a:spcPts val="0"/>
+                </a:spcBef>
+                <a:spcAft>
+                  <a:spcPts val="0"/>
+                </a:spcAft>
+                <a:buClrTx/>
+                <a:buSzTx/>
+                <a:buFontTx/>
+                <a:buNone/>
+                <a:tabLst/>
+                <a:defRPr/>
+              </a:pPr>
+              <a:r>
+                <a:rPr kumimoji="0" lang="en-US" altLang="de-DE" sz="1600" b="0" i="0" u="sng" strike="noStrike" kern="0" cap="none" spc="0" normalizeH="0" baseline="0" noProof="0" dirty="0">
+                  <a:ln>
+                    <a:noFill/>
+                  </a:ln>
+                  <a:solidFill>
+                    <a:prstClr val="black"/>
+                  </a:solidFill>
+                  <a:effectLst/>
+                  <a:uLnTx/>
+                  <a:uFillTx/>
+                  <a:latin typeface="Arial" panose="020B0604020202020204" pitchFamily="34" charset="0"/>
+                  <a:ea typeface="ＭＳ Ｐゴシック" panose="020B0600070205080204" pitchFamily="34" charset="-128"/>
+                </a:rPr>
+                <a:t>:Channel</a:t>
+              </a:r>
+            </a:p>
+          </p:txBody>
+        </p:sp>
+        <p:sp>
+          <p:nvSpPr>
+            <p:cNvPr id="179" name="Rectangle 83">
+              <a:extLst>
+                <a:ext uri="{FF2B5EF4-FFF2-40B4-BE49-F238E27FC236}">
+                  <a16:creationId xmlns:a16="http://schemas.microsoft.com/office/drawing/2014/main" id="{462DDA9D-AA37-883A-A946-2BABF155147E}"/>
+                </a:ext>
+              </a:extLst>
+            </p:cNvPr>
+            <p:cNvSpPr>
+              <a:spLocks noChangeArrowheads="1"/>
+            </p:cNvSpPr>
+            <p:nvPr/>
+          </p:nvSpPr>
+          <p:spPr bwMode="auto">
+            <a:xfrm>
+              <a:off x="4353342" y="1861556"/>
+              <a:ext cx="3281668" cy="412750"/>
+            </a:xfrm>
+            <a:prstGeom prst="rect">
+              <a:avLst/>
+            </a:prstGeom>
+            <a:noFill/>
+            <a:ln w="9525">
+              <a:solidFill>
+                <a:sysClr val="windowText" lastClr="000000"/>
+              </a:solidFill>
+              <a:miter lim="800000"/>
+              <a:headEnd/>
+              <a:tailEnd/>
+            </a:ln>
+          </p:spPr>
+          <p:txBody>
+            <a:bodyPr wrap="none" anchor="ctr"/>
+            <a:lstStyle/>
+            <a:p>
+              <a:pPr marL="0" marR="0" lvl="0" indent="0" defTabSz="914400" eaLnBrk="0" fontAlgn="auto" latinLnBrk="0" hangingPunct="0">
+                <a:lnSpc>
+                  <a:spcPct val="100000"/>
+                </a:lnSpc>
+                <a:spcBef>
+                  <a:spcPts val="0"/>
+                </a:spcBef>
+                <a:spcAft>
+                  <a:spcPts val="0"/>
+                </a:spcAft>
+                <a:buClrTx/>
+                <a:buSzTx/>
+                <a:buFontTx/>
+                <a:buNone/>
+                <a:tabLst/>
+                <a:defRPr/>
+              </a:pPr>
+              <a:endParaRPr kumimoji="0" lang="en-US" sz="1800" b="0" i="0" u="none" strike="noStrike" kern="0" cap="none" spc="0" normalizeH="0" baseline="0" noProof="0" dirty="0">
+                <a:ln>
+                  <a:noFill/>
+                </a:ln>
+                <a:solidFill>
+                  <a:prstClr val="black"/>
+                </a:solidFill>
+                <a:effectLst/>
+                <a:uLnTx/>
+                <a:uFillTx/>
+                <a:latin typeface="Arial" panose="020B0604020202020204" pitchFamily="34" charset="0"/>
+                <a:ea typeface="ＭＳ Ｐゴシック" panose="020B0600070205080204" pitchFamily="34" charset="-128"/>
+              </a:endParaRPr>
+            </a:p>
+          </p:txBody>
+        </p:sp>
+      </p:grpSp>
+      <p:sp>
+        <p:nvSpPr>
+          <p:cNvPr id="181" name="Rectangle 83">
+            <a:extLst>
+              <a:ext uri="{FF2B5EF4-FFF2-40B4-BE49-F238E27FC236}">
+                <a16:creationId xmlns:a16="http://schemas.microsoft.com/office/drawing/2014/main" id="{EAE99CFE-66CC-206B-4368-DC29249DAFF7}"/>
+              </a:ext>
+            </a:extLst>
+          </p:cNvPr>
+          <p:cNvSpPr>
+            <a:spLocks noChangeArrowheads="1"/>
+          </p:cNvSpPr>
+          <p:nvPr/>
+        </p:nvSpPr>
+        <p:spPr bwMode="auto">
+          <a:xfrm>
+            <a:off x="11536173" y="3710410"/>
+            <a:ext cx="271084" cy="219291"/>
+          </a:xfrm>
+          <a:prstGeom prst="rect">
+            <a:avLst/>
+          </a:prstGeom>
+          <a:noFill/>
+          <a:ln w="9525">
+            <a:solidFill>
+              <a:sysClr val="windowText" lastClr="000000"/>
+            </a:solidFill>
+            <a:miter lim="800000"/>
+            <a:headEnd/>
+            <a:tailEnd/>
+          </a:ln>
+        </p:spPr>
+        <p:txBody>
+          <a:bodyPr wrap="none" anchor="ctr"/>
+          <a:lstStyle/>
+          <a:p>
+            <a:pPr algn="ctr" fontAlgn="auto">
+              <a:spcBef>
+                <a:spcPts val="0"/>
+              </a:spcBef>
+              <a:spcAft>
+                <a:spcPts val="0"/>
+              </a:spcAft>
+              <a:defRPr/>
+            </a:pPr>
+            <a:r>
+              <a:rPr lang="en-US" sz="1200" dirty="0">
+                <a:solidFill>
+                  <a:srgbClr val="000000"/>
+                </a:solidFill>
+              </a:rPr>
+              <a:t>“f”</a:t>
+            </a:r>
+            <a:endParaRPr lang="en-US" sz="1800" dirty="0"/>
+          </a:p>
+        </p:txBody>
+      </p:sp>
+      <p:cxnSp>
+        <p:nvCxnSpPr>
+          <p:cNvPr id="182" name="Verbinder: gewinkelt 87">
+            <a:extLst>
+              <a:ext uri="{FF2B5EF4-FFF2-40B4-BE49-F238E27FC236}">
+                <a16:creationId xmlns:a16="http://schemas.microsoft.com/office/drawing/2014/main" id="{ED0BF0F0-F475-BB9F-E2AC-7BA9898CEF48}"/>
+              </a:ext>
+            </a:extLst>
+          </p:cNvPr>
+          <p:cNvCxnSpPr>
+            <a:cxnSpLocks/>
+            <a:stCxn id="181" idx="2"/>
+            <a:endCxn id="179" idx="3"/>
+          </p:cNvCxnSpPr>
+          <p:nvPr/>
+        </p:nvCxnSpPr>
+        <p:spPr>
+          <a:xfrm rot="5400000">
+            <a:off x="10821087" y="4314141"/>
+            <a:ext cx="1235069" cy="466188"/>
+          </a:xfrm>
+          <a:prstGeom prst="bentConnector2">
+            <a:avLst/>
+          </a:prstGeom>
+          <a:noFill/>
+          <a:ln w="9525">
+            <a:solidFill>
+              <a:sysClr val="windowText" lastClr="000000"/>
+            </a:solidFill>
+            <a:round/>
+            <a:headEnd/>
+            <a:tailEnd type="triangle" w="med" len="med"/>
+          </a:ln>
+        </p:spPr>
+      </p:cxnSp>
+      <p:cxnSp>
+        <p:nvCxnSpPr>
+          <p:cNvPr id="195" name="Verbinder: gewinkelt 87">
+            <a:extLst>
+              <a:ext uri="{FF2B5EF4-FFF2-40B4-BE49-F238E27FC236}">
+                <a16:creationId xmlns:a16="http://schemas.microsoft.com/office/drawing/2014/main" id="{062A505B-EF81-CA2D-6853-8C1D418BB241}"/>
+              </a:ext>
+            </a:extLst>
+          </p:cNvPr>
+          <p:cNvCxnSpPr>
+            <a:cxnSpLocks/>
+            <a:stCxn id="32" idx="2"/>
+            <a:endCxn id="179" idx="1"/>
+          </p:cNvCxnSpPr>
+          <p:nvPr/>
+        </p:nvCxnSpPr>
+        <p:spPr>
+          <a:xfrm rot="16200000" flipH="1">
+            <a:off x="7319453" y="2257832"/>
+            <a:ext cx="3171393" cy="2642481"/>
+          </a:xfrm>
+          <a:prstGeom prst="bentConnector2">
+            <a:avLst/>
+          </a:prstGeom>
+          <a:noFill/>
+          <a:ln w="9525">
+            <a:solidFill>
+              <a:sysClr val="windowText" lastClr="000000"/>
+            </a:solidFill>
+            <a:round/>
+            <a:headEnd/>
+            <a:tailEnd type="triangle" w="med" len="med"/>
+          </a:ln>
+        </p:spPr>
+      </p:cxnSp>
+      <p:sp>
+        <p:nvSpPr>
+          <p:cNvPr id="199" name="AutoShape 40">
+            <a:extLst>
+              <a:ext uri="{FF2B5EF4-FFF2-40B4-BE49-F238E27FC236}">
+                <a16:creationId xmlns:a16="http://schemas.microsoft.com/office/drawing/2014/main" id="{EC04A8A2-BAE9-18FD-47CD-DA823EC186F2}"/>
+              </a:ext>
+            </a:extLst>
+          </p:cNvPr>
+          <p:cNvSpPr>
+            <a:spLocks noChangeArrowheads="1"/>
+          </p:cNvSpPr>
+          <p:nvPr/>
+        </p:nvSpPr>
+        <p:spPr bwMode="auto">
+          <a:xfrm flipV="1">
+            <a:off x="11129894" y="976738"/>
+            <a:ext cx="932720" cy="304800"/>
+          </a:xfrm>
+          <a:prstGeom prst="foldedCorner">
+            <a:avLst>
+              <a:gd name="adj" fmla="val 27606"/>
+            </a:avLst>
+          </a:prstGeom>
+          <a:solidFill>
+            <a:srgbClr val="FFFFFF"/>
+          </a:solidFill>
+          <a:ln w="9525">
+            <a:solidFill>
+              <a:srgbClr val="000000"/>
+            </a:solidFill>
+            <a:round/>
+            <a:headEnd/>
+            <a:tailEnd/>
+          </a:ln>
+        </p:spPr>
+        <p:txBody>
+          <a:bodyPr rot="10800000" wrap="none" anchor="ctr" anchorCtr="1"/>
+          <a:lstStyle/>
+          <a:p>
+            <a:pPr marL="0" marR="0" lvl="0" indent="0" algn="l" defTabSz="914400" rtl="0" eaLnBrk="0" fontAlgn="auto" latinLnBrk="0" hangingPunct="0">
+              <a:lnSpc>
+                <a:spcPct val="70000"/>
+              </a:lnSpc>
+              <a:spcBef>
+                <a:spcPts val="0"/>
+              </a:spcBef>
+              <a:spcAft>
+                <a:spcPts val="0"/>
+              </a:spcAft>
+              <a:buClrTx/>
+              <a:buSzTx/>
+              <a:buFontTx/>
+              <a:buNone/>
+              <a:tabLst/>
+              <a:defRPr/>
+            </a:pPr>
+            <a:r>
+              <a:rPr lang="en-US" altLang="de-DE" sz="1600" dirty="0">
+                <a:solidFill>
+                  <a:srgbClr val="000000"/>
+                </a:solidFill>
+                <a:latin typeface="Arial"/>
+                <a:ea typeface="+mn-ea"/>
+              </a:rPr>
+              <a:t>FSM OD</a:t>
+            </a:r>
+            <a:endParaRPr kumimoji="0" lang="en-US" altLang="de-DE" sz="1600" b="0" i="0" u="none" strike="noStrike" kern="1200" cap="none" spc="0" normalizeH="0" baseline="0" dirty="0">
+              <a:ln>
+                <a:noFill/>
+              </a:ln>
+              <a:solidFill>
+                <a:srgbClr val="000000"/>
+              </a:solidFill>
+              <a:effectLst/>
+              <a:uLnTx/>
+              <a:uFillTx/>
+              <a:latin typeface="Arial"/>
+              <a:ea typeface="+mn-ea"/>
+              <a:cs typeface="+mn-cs"/>
+            </a:endParaRPr>
+          </a:p>
+        </p:txBody>
+      </p:sp>
+      <p:sp>
+        <p:nvSpPr>
+          <p:cNvPr id="203" name="Textfeld 44">
+            <a:extLst>
+              <a:ext uri="{FF2B5EF4-FFF2-40B4-BE49-F238E27FC236}">
+                <a16:creationId xmlns:a16="http://schemas.microsoft.com/office/drawing/2014/main" id="{AD9BB030-12E9-1F59-CFE9-D30C1B477387}"/>
+              </a:ext>
+            </a:extLst>
+          </p:cNvPr>
+          <p:cNvSpPr txBox="1"/>
+          <p:nvPr/>
+        </p:nvSpPr>
+        <p:spPr>
+          <a:xfrm>
+            <a:off x="3402189" y="4827409"/>
+            <a:ext cx="2845721" cy="830997"/>
+          </a:xfrm>
+          <a:prstGeom prst="rect">
+            <a:avLst/>
+          </a:prstGeom>
+          <a:noFill/>
+        </p:spPr>
+        <p:txBody>
+          <a:bodyPr wrap="square" rtlCol="0">
+            <a:spAutoFit/>
+          </a:bodyPr>
+          <a:lstStyle/>
+          <a:p>
+            <a:pPr eaLnBrk="0" hangingPunct="0"/>
+            <a:r>
+              <a:rPr lang="en-US" sz="1600" i="1" dirty="0">
+                <a:solidFill>
+                  <a:srgbClr val="00549F"/>
+                </a:solidFill>
+                <a:latin typeface="Trebuchet MS" panose="020B0603020202020204" pitchFamily="34" charset="0"/>
+                <a:cs typeface="Times New Roman" panose="02020603050405020304" pitchFamily="18" charset="0"/>
+              </a:rPr>
+              <a:t>Models of both languages can be mapped onto the function structure model</a:t>
+            </a:r>
+            <a:endParaRPr lang="en-US" sz="1600" i="1" dirty="0">
+              <a:solidFill>
+                <a:srgbClr val="00549F"/>
+              </a:solidFill>
+              <a:latin typeface="Trebuchet MS" panose="020B0603020202020204" pitchFamily="34" charset="0"/>
+              <a:ea typeface="ＭＳ Ｐゴシック" panose="020B0600070205080204" pitchFamily="34" charset="-128"/>
+              <a:cs typeface="Times New Roman" panose="02020603050405020304" pitchFamily="18" charset="0"/>
+            </a:endParaRPr>
+          </a:p>
+        </p:txBody>
+      </p:sp>
+      <p:sp>
+        <p:nvSpPr>
+          <p:cNvPr id="204" name="Freihandform: Form 44">
+            <a:extLst>
+              <a:ext uri="{FF2B5EF4-FFF2-40B4-BE49-F238E27FC236}">
+                <a16:creationId xmlns:a16="http://schemas.microsoft.com/office/drawing/2014/main" id="{4DFF790C-CEB4-4BF6-3353-1A8F12B62C41}"/>
+              </a:ext>
+            </a:extLst>
+          </p:cNvPr>
+          <p:cNvSpPr/>
+          <p:nvPr/>
+        </p:nvSpPr>
+        <p:spPr>
+          <a:xfrm rot="15900922">
+            <a:off x="6005378" y="3350991"/>
+            <a:ext cx="302982" cy="2040713"/>
+          </a:xfrm>
+          <a:custGeom>
+            <a:avLst/>
+            <a:gdLst>
+              <a:gd name="connsiteX0" fmla="*/ 197910 w 197910"/>
+              <a:gd name="connsiteY0" fmla="*/ 0 h 339970"/>
+              <a:gd name="connsiteX1" fmla="*/ 4479 w 197910"/>
+              <a:gd name="connsiteY1" fmla="*/ 58616 h 339970"/>
+              <a:gd name="connsiteX2" fmla="*/ 80679 w 197910"/>
+              <a:gd name="connsiteY2" fmla="*/ 339970 h 339970"/>
+            </a:gdLst>
+            <a:ahLst/>
+            <a:cxnLst>
+              <a:cxn ang="0">
+                <a:pos x="connsiteX0" y="connsiteY0"/>
+              </a:cxn>
+              <a:cxn ang="0">
+                <a:pos x="connsiteX1" y="connsiteY1"/>
+              </a:cxn>
+              <a:cxn ang="0">
+                <a:pos x="connsiteX2" y="connsiteY2"/>
+              </a:cxn>
+            </a:cxnLst>
+            <a:rect l="l" t="t" r="r" b="b"/>
+            <a:pathLst>
+              <a:path w="197910" h="339970">
+                <a:moveTo>
+                  <a:pt x="197910" y="0"/>
+                </a:moveTo>
+                <a:cubicBezTo>
+                  <a:pt x="110963" y="977"/>
+                  <a:pt x="24017" y="1954"/>
+                  <a:pt x="4479" y="58616"/>
+                </a:cubicBezTo>
+                <a:cubicBezTo>
+                  <a:pt x="-15060" y="115278"/>
+                  <a:pt x="32809" y="227624"/>
+                  <a:pt x="80679" y="339970"/>
+                </a:cubicBezTo>
+              </a:path>
+            </a:pathLst>
+          </a:custGeom>
+          <a:noFill/>
+          <a:ln w="12700" cap="flat" cmpd="sng" algn="ctr">
+            <a:solidFill>
+              <a:srgbClr val="00549F"/>
+            </a:solidFill>
+            <a:prstDash val="solid"/>
+            <a:miter lim="800000"/>
+            <a:headEnd type="none" w="med" len="med"/>
+            <a:tailEnd type="arrow" w="med" len="med"/>
+          </a:ln>
+          <a:effectLst/>
+        </p:spPr>
+        <p:txBody>
+          <a:bodyPr rtlCol="0" anchor="ctr"/>
+          <a:lstStyle/>
+          <a:p>
+            <a:pPr marL="0" marR="0" lvl="0" indent="0" algn="ctr" defTabSz="914400" eaLnBrk="0" fontAlgn="auto" latinLnBrk="0" hangingPunct="0">
+              <a:lnSpc>
+                <a:spcPct val="100000"/>
+              </a:lnSpc>
+              <a:spcBef>
+                <a:spcPts val="0"/>
+              </a:spcBef>
+              <a:spcAft>
+                <a:spcPts val="0"/>
+              </a:spcAft>
+              <a:buClrTx/>
+              <a:buSzTx/>
+              <a:buFontTx/>
+              <a:buNone/>
+              <a:tabLst/>
+              <a:defRPr/>
+            </a:pPr>
+            <a:endParaRPr kumimoji="0" lang="en-US" sz="1800" b="0" i="0" u="none" strike="noStrike" kern="0" cap="none" spc="0" normalizeH="0" baseline="0" noProof="0">
+              <a:ln>
+                <a:noFill/>
+              </a:ln>
+              <a:solidFill>
+                <a:prstClr val="white"/>
+              </a:solidFill>
+              <a:effectLst/>
+              <a:uLnTx/>
+              <a:uFillTx/>
+              <a:latin typeface="Arial"/>
+              <a:ea typeface="+mn-ea"/>
+              <a:cs typeface="+mn-cs"/>
+            </a:endParaRPr>
+          </a:p>
+        </p:txBody>
+      </p:sp>
+      <p:sp>
+        <p:nvSpPr>
+          <p:cNvPr id="205" name="Freihandform: Form 44">
+            <a:extLst>
+              <a:ext uri="{FF2B5EF4-FFF2-40B4-BE49-F238E27FC236}">
+                <a16:creationId xmlns:a16="http://schemas.microsoft.com/office/drawing/2014/main" id="{6C085B49-0BD9-1EFE-0B1B-B93D11AF8BD2}"/>
+              </a:ext>
+            </a:extLst>
+          </p:cNvPr>
+          <p:cNvSpPr/>
+          <p:nvPr/>
+        </p:nvSpPr>
+        <p:spPr>
+          <a:xfrm rot="16200000">
+            <a:off x="4474693" y="2067311"/>
+            <a:ext cx="514253" cy="4875448"/>
+          </a:xfrm>
+          <a:custGeom>
+            <a:avLst/>
+            <a:gdLst>
+              <a:gd name="connsiteX0" fmla="*/ 197910 w 197910"/>
+              <a:gd name="connsiteY0" fmla="*/ 0 h 339970"/>
+              <a:gd name="connsiteX1" fmla="*/ 4479 w 197910"/>
+              <a:gd name="connsiteY1" fmla="*/ 58616 h 339970"/>
+              <a:gd name="connsiteX2" fmla="*/ 80679 w 197910"/>
+              <a:gd name="connsiteY2" fmla="*/ 339970 h 339970"/>
+            </a:gdLst>
+            <a:ahLst/>
+            <a:cxnLst>
+              <a:cxn ang="0">
+                <a:pos x="connsiteX0" y="connsiteY0"/>
+              </a:cxn>
+              <a:cxn ang="0">
+                <a:pos x="connsiteX1" y="connsiteY1"/>
+              </a:cxn>
+              <a:cxn ang="0">
+                <a:pos x="connsiteX2" y="connsiteY2"/>
+              </a:cxn>
+            </a:cxnLst>
+            <a:rect l="l" t="t" r="r" b="b"/>
+            <a:pathLst>
+              <a:path w="197910" h="339970">
+                <a:moveTo>
+                  <a:pt x="197910" y="0"/>
+                </a:moveTo>
+                <a:cubicBezTo>
+                  <a:pt x="110963" y="977"/>
+                  <a:pt x="24017" y="1954"/>
+                  <a:pt x="4479" y="58616"/>
+                </a:cubicBezTo>
+                <a:cubicBezTo>
+                  <a:pt x="-15060" y="115278"/>
+                  <a:pt x="32809" y="227624"/>
+                  <a:pt x="80679" y="339970"/>
+                </a:cubicBezTo>
+              </a:path>
+            </a:pathLst>
+          </a:custGeom>
+          <a:noFill/>
+          <a:ln w="12700" cap="flat" cmpd="sng" algn="ctr">
+            <a:solidFill>
+              <a:srgbClr val="00549F"/>
+            </a:solidFill>
+            <a:prstDash val="solid"/>
+            <a:miter lim="800000"/>
+            <a:headEnd type="none" w="med" len="med"/>
+            <a:tailEnd type="arrow" w="med" len="med"/>
+          </a:ln>
+          <a:effectLst/>
+        </p:spPr>
+        <p:txBody>
+          <a:bodyPr rtlCol="0" anchor="ctr"/>
+          <a:lstStyle/>
+          <a:p>
+            <a:pPr marL="0" marR="0" lvl="0" indent="0" algn="ctr" defTabSz="914400" eaLnBrk="0" fontAlgn="auto" latinLnBrk="0" hangingPunct="0">
+              <a:lnSpc>
+                <a:spcPct val="100000"/>
+              </a:lnSpc>
+              <a:spcBef>
+                <a:spcPts val="0"/>
+              </a:spcBef>
+              <a:spcAft>
+                <a:spcPts val="0"/>
+              </a:spcAft>
+              <a:buClrTx/>
+              <a:buSzTx/>
+              <a:buFontTx/>
+              <a:buNone/>
+              <a:tabLst/>
+              <a:defRPr/>
+            </a:pPr>
+            <a:endParaRPr kumimoji="0" lang="en-US" sz="1800" b="0" i="0" u="none" strike="noStrike" kern="0" cap="none" spc="0" normalizeH="0" baseline="0" noProof="0">
+              <a:ln>
+                <a:noFill/>
+              </a:ln>
+              <a:solidFill>
+                <a:prstClr val="white"/>
+              </a:solidFill>
+              <a:effectLst/>
+              <a:uLnTx/>
+              <a:uFillTx/>
+              <a:latin typeface="Arial"/>
+              <a:ea typeface="+mn-ea"/>
+              <a:cs typeface="+mn-cs"/>
+            </a:endParaRPr>
+          </a:p>
+        </p:txBody>
+      </p:sp>
+      <p:sp>
+        <p:nvSpPr>
+          <p:cNvPr id="207" name="Rectangle 206">
+            <a:extLst>
+              <a:ext uri="{FF2B5EF4-FFF2-40B4-BE49-F238E27FC236}">
+                <a16:creationId xmlns:a16="http://schemas.microsoft.com/office/drawing/2014/main" id="{D69337F2-FB32-B456-2D32-96C1A0EB15E2}"/>
+              </a:ext>
+            </a:extLst>
+          </p:cNvPr>
+          <p:cNvSpPr/>
+          <p:nvPr/>
+        </p:nvSpPr>
+        <p:spPr>
+          <a:xfrm>
+            <a:off x="7169543" y="974614"/>
+            <a:ext cx="4893071" cy="4788988"/>
+          </a:xfrm>
+          <a:prstGeom prst="rect">
+            <a:avLst/>
+          </a:prstGeom>
+          <a:noFill/>
+          <a:ln w="6350">
+            <a:solidFill>
+              <a:schemeClr val="tx1"/>
+            </a:solidFill>
+            <a:headEnd type="none" w="med" len="med"/>
+            <a:tailEnd type="arrow" w="med" len="med"/>
+          </a:ln>
+        </p:spPr>
+        <p:style>
+          <a:lnRef idx="2">
+            <a:schemeClr val="accent1">
+              <a:shade val="50000"/>
+            </a:schemeClr>
+          </a:lnRef>
+          <a:fillRef idx="1">
+            <a:schemeClr val="accent1"/>
+          </a:fillRef>
+          <a:effectRef idx="0">
+            <a:schemeClr val="accent1"/>
+          </a:effectRef>
+          <a:fontRef idx="minor">
+            <a:schemeClr val="lt1"/>
+          </a:fontRef>
+        </p:style>
+        <p:txBody>
+          <a:bodyPr rtlCol="0" anchor="ctr"/>
+          <a:lstStyle/>
+          <a:p>
+            <a:pPr algn="ctr"/>
+            <a:endParaRPr lang="en-DE"/>
+          </a:p>
+        </p:txBody>
+      </p:sp>
+    </p:spTree>
+    <p:extLst>
+      <p:ext uri="{BB962C8B-B14F-4D97-AF65-F5344CB8AC3E}">
+        <p14:creationId xmlns:p14="http://schemas.microsoft.com/office/powerpoint/2010/main" val="1924946569"/>
+      </p:ext>
+    </p:extLst>
+  </p:cSld>
+  <p:clrMapOvr>
+    <a:masterClrMapping/>
+  </p:clrMapOvr>
+</p:sld>
+</file>
+
+<file path=ppt/slides/slide2.xml><?xml version="1.0" encoding="utf-8"?>
 <p:sld xmlns:a="http://schemas.openxmlformats.org/drawingml/2006/main" xmlns:r="http://schemas.openxmlformats.org/officeDocument/2006/relationships" xmlns:p="http://schemas.openxmlformats.org/presentationml/2006/main">
   <p:cSld>
     <p:spTree>
@@ -18369,7 +21945,7 @@
 </p:sld>
 </file>
 
-<file path=ppt/slides/slide2.xml><?xml version="1.0" encoding="utf-8"?>
+<file path=ppt/slides/slide3.xml><?xml version="1.0" encoding="utf-8"?>
 <p:sld xmlns:a="http://schemas.openxmlformats.org/drawingml/2006/main" xmlns:r="http://schemas.openxmlformats.org/officeDocument/2006/relationships" xmlns:p="http://schemas.openxmlformats.org/presentationml/2006/main">
   <p:cSld>
     <p:spTree>

</xml_diff>